<commit_message>
Update Locke Research Update Mar2026.pptx
</commit_message>
<xml_diff>
--- a/archive/Presentations/Locke Research Update Mar2026.pptx
+++ b/archive/Presentations/Locke Research Update Mar2026.pptx
@@ -11,7 +11,7 @@
     <p:sldId id="954" r:id="rId2"/>
     <p:sldId id="926" r:id="rId3"/>
     <p:sldId id="933" r:id="rId4"/>
-    <p:sldId id="956" r:id="rId5"/>
+    <p:sldId id="966" r:id="rId5"/>
     <p:sldId id="940" r:id="rId6"/>
     <p:sldId id="876" r:id="rId7"/>
     <p:sldId id="862" r:id="rId8"/>
@@ -205,7 +205,7 @@
           <a:p>
             <a:fld id="{5743F77F-9A3C-E740-9DB0-E9D6C9A5452C}" type="datetimeFigureOut">
               <a:rPr lang="en-US" smtClean="0"/>
-              <a:t>3/7/26</a:t>
+              <a:t>3/12/26</a:t>
             </a:fld>
             <a:endParaRPr lang="en-US"/>
           </a:p>
@@ -516,473 +516,6 @@
           <a:bodyPr/>
           <a:lstStyle/>
           <a:p>
-            <a:r>
-              <a:rPr lang="en-US" dirty="0"/>
-              <a:t>Transcript of the talk: (dictated, forgive errors)</a:t>
-            </a:r>
-          </a:p>
-          <a:p>
-            <a:endParaRPr lang="en-US" dirty="0"/>
-          </a:p>
-          <a:p>
-            <a:r>
-              <a:rPr lang="en-US" dirty="0"/>
-              <a:t>My name is Brian Locke. I’m an assistant professor working in the Shock Trauma ICU and the Schmidt Chest Clinic, and today I’m giving an update on hypercapnic respiratory failure. I have a conflict of interest with a local startup doing machine learning unrelated to this talk. I want to acknowledge support from the American Thoracic Society, the NIH, and our Pulmonary and Critical Care Medicine seed grant, and to thank the Utah Population Database and its funders. For those following along in </a:t>
-            </a:r>
-            <a:r>
-              <a:rPr lang="en-US" dirty="0" err="1"/>
-              <a:t>NotebookLM</a:t>
-            </a:r>
-            <a:r>
-              <a:rPr lang="en-US" dirty="0"/>
-              <a:t>, Google’s large language model environment, I’ve uploaded key literature so you can query or review the synthesized notes while we go.</a:t>
-            </a:r>
-          </a:p>
-          <a:p>
-            <a:br>
-              <a:rPr lang="en-US" dirty="0"/>
-            </a:br>
-            <a:endParaRPr lang="en-US" dirty="0"/>
-          </a:p>
-          <a:p>
-            <a:r>
-              <a:rPr lang="en-US" dirty="0"/>
-              <a:t>I’ll start with background and the current state of hypercapnic respiratory failure, move to what we’re doing clinically and in research, and end with new CMS national coverage determinations for respiratory assist devices and home mechanical ventilators—changes most private payers will soon mirror—so we can discuss how to qualify patients for devices.</a:t>
-            </a:r>
-          </a:p>
-          <a:p>
-            <a:br>
-              <a:rPr lang="en-US" dirty="0"/>
-            </a:br>
-            <a:endParaRPr lang="en-US" dirty="0"/>
-          </a:p>
-          <a:p>
-            <a:r>
-              <a:rPr lang="en-US" dirty="0"/>
-              <a:t>First, definitions. Hypercapnic respiratory failure is a syndrome—the pattern of signs and symptoms that accompany a CO₂ level that is too high—reflecting failed homeostasis: an imbalance between tissue CO₂ production and alveolar ventilation that allows </a:t>
-            </a:r>
-            <a:r>
-              <a:rPr lang="en-US" dirty="0" err="1"/>
-              <a:t>PaCO</a:t>
-            </a:r>
-            <a:r>
-              <a:rPr lang="en-US" dirty="0"/>
-              <a:t>₂ to rise. Hypercapnia itself is a finding defined against the distribution of normal values. Because “normal” shifts with altitude, the threshold for abnormality is lower here than at sea level; using 41–42 mmHg in Salt Lake City is appropriate. Payers don’t adjust coverage criteria for elevation, which may not matter for borderline cases clinically, but it matters for how we interpret a clinic </a:t>
-            </a:r>
-            <a:r>
-              <a:rPr lang="en-US" dirty="0" err="1"/>
-              <a:t>PaCO</a:t>
-            </a:r>
-            <a:r>
-              <a:rPr lang="en-US" dirty="0"/>
-              <a:t>₂ of 43–44 mmHg locally—that’s abnormal. Although one might imagine adding criteria (for example, excluding cases where elevated </a:t>
-            </a:r>
-            <a:r>
-              <a:rPr lang="en-US" dirty="0" err="1"/>
-              <a:t>PaCO</a:t>
-            </a:r>
-            <a:r>
-              <a:rPr lang="en-US" dirty="0"/>
-              <a:t>₂ is a proportional response to metabolic alkalosis—what I’d call “respiratory success”), </a:t>
-            </a:r>
-            <a:r>
-              <a:rPr lang="en-US" dirty="0" err="1"/>
-              <a:t>TriNetX</a:t>
-            </a:r>
-            <a:r>
-              <a:rPr lang="en-US" dirty="0"/>
-              <a:t> data suggest isolated, compensatory hypercapnia is rare. In practice, the syndrome is defined by a high CO₂.</a:t>
-            </a:r>
-          </a:p>
-          <a:p>
-            <a:br>
-              <a:rPr lang="en-US" dirty="0"/>
-            </a:br>
-            <a:endParaRPr lang="en-US" dirty="0"/>
-          </a:p>
-          <a:p>
-            <a:r>
-              <a:rPr lang="en-US" dirty="0"/>
-              <a:t>I prefer the term ventilatory failure because homeostasis can fail without overt hypercapnia when the physiologic context calls for a lower </a:t>
-            </a:r>
-            <a:r>
-              <a:rPr lang="en-US" dirty="0" err="1"/>
-              <a:t>PaCO</a:t>
-            </a:r>
-            <a:r>
-              <a:rPr lang="en-US" dirty="0"/>
-              <a:t>₂. The framework I use is supply versus demand: can the patient sustain the ventilation the situation requires? Demand depends on three variables: the dead-space fraction (the portion of each breath wasted for CO₂ exchange), tissue CO₂ production, and the target </a:t>
-            </a:r>
-            <a:r>
-              <a:rPr lang="en-US" dirty="0" err="1"/>
-              <a:t>PaCO</a:t>
-            </a:r>
-            <a:r>
-              <a:rPr lang="en-US" dirty="0"/>
-              <a:t>₂ appropriate to the situation. If dead space increases, required ventilation rises. If CO₂ production rises, required ventilation rises proportionally. If the target </a:t>
-            </a:r>
-            <a:r>
-              <a:rPr lang="en-US" dirty="0" err="1"/>
-              <a:t>PaCO</a:t>
-            </a:r>
-            <a:r>
-              <a:rPr lang="en-US" dirty="0"/>
-              <a:t>₂ is lower, required ventilation climbs nonlinearly.</a:t>
-            </a:r>
-          </a:p>
-          <a:p>
-            <a:br>
-              <a:rPr lang="en-US" dirty="0"/>
-            </a:br>
-            <a:endParaRPr lang="en-US" dirty="0"/>
-          </a:p>
-          <a:p>
-            <a:r>
-              <a:rPr lang="en-US" dirty="0"/>
-              <a:t>Supply—the maximal sustainable ventilation—depends on respiratory muscle capacity and mechanical advantage, the stability of respiratory control, and the loads on the system. Loads include resistive loads (like breathing through a straw), elastic loads (inflating a stiff lung or chest wall), and, in many acute settings, threshold and inertial loads. Opioids and sleep alter control stability; COPD with hyperinflation, neuromuscular disease, and pleural or chest wall disease alter mechanics. Patients whose chronic loads push them close to their sustainable limit have little physiologic reserve. Think of a person with COPD whose FEV₁ is well under a liter: a small increase in demand can precipitate failure. Those are the patients who need close attention, as highlighted by prior work in this area.</a:t>
-            </a:r>
-          </a:p>
-          <a:p>
-            <a:br>
-              <a:rPr lang="en-US" dirty="0"/>
-            </a:br>
-            <a:endParaRPr lang="en-US" dirty="0"/>
-          </a:p>
-          <a:p>
-            <a:r>
-              <a:rPr lang="en-US" dirty="0"/>
-              <a:t>It’s worth dwelling on the goal </a:t>
-            </a:r>
-            <a:r>
-              <a:rPr lang="en-US" dirty="0" err="1"/>
-              <a:t>PaCO</a:t>
-            </a:r>
-            <a:r>
-              <a:rPr lang="en-US" dirty="0"/>
-              <a:t>₂. Mathematically, a higher </a:t>
-            </a:r>
-            <a:r>
-              <a:rPr lang="en-US" dirty="0" err="1"/>
-              <a:t>PaCO</a:t>
-            </a:r>
-            <a:r>
-              <a:rPr lang="en-US" dirty="0"/>
-              <a:t>₂ target lowers required ventilation, which can seem counterintuitive. Elevated CO₂ signals a response to some underlying stress, but from a mechanics standpoint, higher alveolar CO₂ allows each exhaled breath to carry a higher CO₂ concentration, reducing the total ventilation needed to maintain steady state. That’s the rationale for permissive hypercapnia in lung-protective ventilation: allowing </a:t>
-            </a:r>
-            <a:r>
-              <a:rPr lang="en-US" dirty="0" err="1"/>
-              <a:t>PaCO</a:t>
-            </a:r>
-            <a:r>
-              <a:rPr lang="en-US" dirty="0"/>
-              <a:t>₂ to rise lets us reduce ventilatory pressures. Evidence from ECMO cohorts and from patients with kidney injury suggests that for a given CO₂ rise, lack of metabolic compensation portends worse outcomes in ARDS, partly reflecting multi-organ failure and partly the ongoing mechanical stress on lungs. This raises a question: if higher </a:t>
-            </a:r>
-            <a:r>
-              <a:rPr lang="en-US" dirty="0" err="1"/>
-              <a:t>PaCO</a:t>
-            </a:r>
-            <a:r>
-              <a:rPr lang="en-US" dirty="0"/>
-              <a:t>₂ lowers ventilatory work and pH can be maintained at any </a:t>
-            </a:r>
-            <a:r>
-              <a:rPr lang="en-US" dirty="0" err="1"/>
-              <a:t>PaCO</a:t>
-            </a:r>
-            <a:r>
-              <a:rPr lang="en-US" dirty="0"/>
-              <a:t>₂ with sufficient bicarbonate, why isn’t the set point much higher—why not a </a:t>
-            </a:r>
-            <a:r>
-              <a:rPr lang="en-US" dirty="0" err="1"/>
-              <a:t>PaCO</a:t>
-            </a:r>
-            <a:r>
-              <a:rPr lang="en-US" dirty="0"/>
-              <a:t>₂ of 90 with a bicarbonate of 45? The answer likely lies in oxygen. By the alveolar gas equation, CO₂ “occupies space” that would otherwise contribute to alveolar oxygen; at room air (</a:t>
-            </a:r>
-            <a:r>
-              <a:rPr lang="en-US" dirty="0" err="1"/>
-              <a:t>FiO</a:t>
-            </a:r>
-            <a:r>
-              <a:rPr lang="en-US" dirty="0"/>
-              <a:t>₂ 0.21), a higher </a:t>
-            </a:r>
-            <a:r>
-              <a:rPr lang="en-US" dirty="0" err="1"/>
-              <a:t>PaCO</a:t>
-            </a:r>
-            <a:r>
-              <a:rPr lang="en-US" dirty="0"/>
-              <a:t>₂ erodes the oxygenation buffer. The transition from acute to chronic hypercapnia seems to involve a control-system calculation that balances the effort of breathing against the cost of reduced oxygen margin. In chronic respiratory failure, the old “can’t breathe/won’t breathe” dichotomy doesn’t help.</a:t>
-            </a:r>
-          </a:p>
-          <a:p>
-            <a:br>
-              <a:rPr lang="en-US" dirty="0"/>
-            </a:br>
-            <a:endParaRPr lang="en-US" dirty="0"/>
-          </a:p>
-          <a:p>
-            <a:r>
-              <a:rPr lang="en-US" dirty="0"/>
-              <a:t>Severe hypercapnia as a survivable state is relatively new in medicine. Before supplemental oxygen, significant hypercapnia generally meant death. Only about 75 years ago did clinicians begin to recognize and treat it. Hannah Wunsch’s The Autumn Ghost recounts how, during the early polio epidemics, somnolence and unresponsiveness were attributed to encephalitis (“</a:t>
-            </a:r>
-            <a:r>
-              <a:rPr lang="en-US" dirty="0" err="1"/>
-              <a:t>cerebrelia</a:t>
-            </a:r>
-            <a:r>
-              <a:rPr lang="en-US" dirty="0"/>
-              <a:t>”) until clinicians provided manual positive-pressure breaths and patients woke up—revealing CO₂ retention as the true cause and inaugurating modern critical care.</a:t>
-            </a:r>
-          </a:p>
-          <a:p>
-            <a:br>
-              <a:rPr lang="en-US" dirty="0"/>
-            </a:br>
-            <a:endParaRPr lang="en-US" dirty="0"/>
-          </a:p>
-          <a:p>
-            <a:r>
-              <a:rPr lang="en-US" dirty="0"/>
-              <a:t>I argue that hypercapnic respiratory failure management is a large, solvable, and neglected problem. On scale: an Australian study in the Blue Journal estimated a population-standardized period prevalence of </a:t>
-            </a:r>
-            <a:r>
-              <a:rPr lang="en-US" dirty="0" err="1"/>
-              <a:t>PaCO</a:t>
-            </a:r>
-            <a:r>
-              <a:rPr lang="en-US" dirty="0"/>
-              <a:t>₂ ≥45 mmHg (excluding iatrogenic causes) of 150 per 100,000 person-years—higher than decompensated cirrhosis in the United States, which is roughly 100 per 100,000. A limitation is that not every patient with hypercapnia gets a blood gas, so ascertainment is imperfect. The only study I know that checked blood gases without clinical indication—a 2005 Denver VA study of consecutive admissions with BMI ≥35—found elevation-adjusted hypercapnia in about a third of patients, with only about one in ten recognized clinically.</a:t>
-            </a:r>
-          </a:p>
-          <a:p>
-            <a:br>
-              <a:rPr lang="en-US" dirty="0"/>
-            </a:br>
-            <a:endParaRPr lang="en-US" dirty="0"/>
-          </a:p>
-          <a:p>
-            <a:r>
-              <a:rPr lang="en-US" dirty="0"/>
-              <a:t>Our group used the Utah Population Database to estimate pre‑COVID yearly period prevalence of ICD codes for hypercapnic respiratory failure in Utah; there were about 4,000–5,000 codes per year across five primary codes, which normalizes to roughly 150 per 100,000—again, in that same ballpark. </a:t>
-            </a:r>
-            <a:r>
-              <a:rPr lang="en-US" dirty="0" err="1"/>
-              <a:t>TriNetX</a:t>
-            </a:r>
-            <a:r>
-              <a:rPr lang="en-US" dirty="0"/>
-              <a:t> analyses help interpret this: among patients with hypercapnia on blood gas, about a third in the ED and about 40% in inpatient settings receive an ICD code for hypercapnic respiratory failure, suggesting code-based counts may underestimate the true burden by up to a factor of three.</a:t>
-            </a:r>
-          </a:p>
-          <a:p>
-            <a:br>
-              <a:rPr lang="en-US" dirty="0"/>
-            </a:br>
-            <a:endParaRPr lang="en-US" dirty="0"/>
-          </a:p>
-          <a:p>
-            <a:r>
-              <a:rPr lang="en-US" dirty="0"/>
-              <a:t>Outcomes are concerning across etiologies. A single-center study from Vermont of inpatients with an ICD code for hypercapnic respiratory failure showed a 30‑day readmission rate of about 25%, similar to heart failure and higher than myocardial infarction, with two-thirds readmitted for recurrent hypercapnia. In the Michigan health system, even compensated hypercapnia on blood gas was associated with increased mortality; a </a:t>
-            </a:r>
-            <a:r>
-              <a:rPr lang="en-US" dirty="0" err="1"/>
-              <a:t>PaCO</a:t>
-            </a:r>
-            <a:r>
-              <a:rPr lang="en-US" dirty="0"/>
-              <a:t>₂ in the 50–65 mmHg range carried a risk roughly comparable to decompensated cirrhosis, with higher </a:t>
-            </a:r>
-            <a:r>
-              <a:rPr lang="en-US" dirty="0" err="1"/>
-              <a:t>PaCO</a:t>
-            </a:r>
-            <a:r>
-              <a:rPr lang="en-US" dirty="0"/>
-              <a:t>₂ worse and milder elevations somewhat better. In </a:t>
-            </a:r>
-            <a:r>
-              <a:rPr lang="en-US" dirty="0" err="1"/>
-              <a:t>TriNetX</a:t>
-            </a:r>
-            <a:r>
-              <a:rPr lang="en-US" dirty="0"/>
-              <a:t> data, among about 30,000 patients with hypercapnic respiratory failure codes (mean age ~65), two‑month mortality was 20% and climbed to about 30% by nine months.</a:t>
-            </a:r>
-          </a:p>
-          <a:p>
-            <a:br>
-              <a:rPr lang="en-US" dirty="0"/>
-            </a:br>
-            <a:endParaRPr lang="en-US" dirty="0"/>
-          </a:p>
-          <a:p>
-            <a:r>
-              <a:rPr lang="en-US" dirty="0"/>
-              <a:t>These patients are also expensive to care for. Office of Inspector General reports document dramatic growth in use of home mechanical ventilators and noninvasive respiratory assist devices beginning around 2013, with more than a hundred‑fold increases relative to 2009 baselines. Comprehensive cost estimates are lacking, which is why one of our first seed‑grant projects is an economic analysis linking Intermountain Health records to Select Health claims. We call this AIM‑HIGH (Artificial Intelligence for Modifiable Health Indicators in Groups with High Needs), starting with hypercapnic respiratory failure and extending to other high‑utilization conditions, using machine learning to identify patients at risk and intervene.</a:t>
-            </a:r>
-          </a:p>
-          <a:p>
-            <a:br>
-              <a:rPr lang="en-US" dirty="0"/>
-            </a:br>
-            <a:endParaRPr lang="en-US" dirty="0"/>
-          </a:p>
-          <a:p>
-            <a:r>
-              <a:rPr lang="en-US" dirty="0"/>
-              <a:t>Therapeutic options exist, although the evidence base is uneven. Guidelines for obesity hypoventilation recommend treatment despite surprisingly low levels of evidence. There are randomized trials in neuromuscular weakness (and in cystic fibrosis, though not discussed today), and there is a dozen‑plus trials of long‑term noninvasive ventilation in chronic stable hypercapnic respiratory failure that are generally supportive when done appropriately. It is not all NIV. Weight‑loss interventions matter for the sleep‑disordered breathing component of hypercapnia. The FDA has approved </a:t>
-            </a:r>
-            <a:r>
-              <a:rPr lang="en-US" dirty="0" err="1"/>
-              <a:t>tirzepatide</a:t>
-            </a:r>
-            <a:r>
-              <a:rPr lang="en-US" dirty="0"/>
-              <a:t> for obstructive sleep apnea, and our meta‑analysis shows a dose‑dependent improvement in OSA with both surgical and medical weight loss. Although we don’t yet know the exact fraction of hypercapnia attributable to sleep apnea, several cohorts that systematically tested ICU survivors of hypercapnic respiratory failure found that the majority had moderate to severe OSA. Even outside strict OHS definitions, sleep apnea likely plays a substantial causal role that we systematically miss without testing.</a:t>
-            </a:r>
-          </a:p>
-          <a:p>
-            <a:br>
-              <a:rPr lang="en-US" dirty="0"/>
-            </a:br>
-            <a:endParaRPr lang="en-US" dirty="0"/>
-          </a:p>
-          <a:p>
-            <a:r>
-              <a:rPr lang="en-US" dirty="0"/>
-              <a:t>These needs have prompted a movement to formalize a subspecialty in chronic respiratory failure. An </a:t>
-            </a:r>
-            <a:r>
-              <a:rPr lang="en-US" dirty="0" err="1"/>
-              <a:t>AnnalsATS</a:t>
-            </a:r>
-            <a:r>
-              <a:rPr lang="en-US" dirty="0"/>
-              <a:t> piece last year makes the case: roughly 300 clinicians nationwide specialize in managing chronic respiratory failure—far too few for current needs—and care requires both device expertise and structured processes around DME ordering and respiratory therapy support. Subspecialty designation could solidify a research paradigm and allow us to advocate for structural changes.</a:t>
-            </a:r>
-          </a:p>
-          <a:p>
-            <a:br>
-              <a:rPr lang="en-US" dirty="0"/>
-            </a:br>
-            <a:endParaRPr lang="en-US" dirty="0"/>
-          </a:p>
-          <a:p>
-            <a:r>
-              <a:rPr lang="en-US" dirty="0"/>
-              <a:t>Two evidence gaps hinder effective care. First, real patients usually have multiple contributing causes for hypercapnia, but most trials target single‑cause cohorts. Trials of hypercapnic COPD often enroll patients with average BMIs around 25 and exclude comorbid sleep apnea; the definition of OHS, in turn, excludes patients with even modest contributions from heart failure or COPD. What should we do for someone with COPD, heart failure, and sleep‑disordered breathing? The evidence rarely applies cleanly, so we extrapolate. Second, the evidence presupposes a definitive diagnosis, whereas in practice hypercapnic respiratory failure often precedes the diagnosis of the causative condition. Patients are admitted without prior spirometry, sleep testing, or sometimes even an established outpatient relationship; they’re stabilized and discharged; testing is ordered but often not completed; and care transitions create opportunities to fall through the cracks.</a:t>
-            </a:r>
-          </a:p>
-          <a:p>
-            <a:br>
-              <a:rPr lang="en-US" dirty="0"/>
-            </a:br>
-            <a:endParaRPr lang="en-US" dirty="0"/>
-          </a:p>
-          <a:p>
-            <a:r>
-              <a:rPr lang="en-US" dirty="0"/>
-              <a:t>We examined statewide testing patterns using the Utah Population Database and the All‑Payer Claims Database (covering ~90% of commercially insured patients and ~70% of other care from 2015–2019). Among patients with inpatient or ED encounters coded for hypercapnic respiratory failure, roughly two‑thirds had an echocardiogram in the five years before the index event, but only about one in three had spirometry and about one in five had sleep testing. In the year after the event—including the index hospitalization—about half received an echocardiogram, but only ~one in eight had spirometry and ~one in ten had sleep testing. These figures likely underestimate testing only slightly (e.g., in‑migrants), and they underscore a system‑level gap. Our CO₂‑PATH cohort (Post‑Acute Trajectories of Hypercapnia) is designed to define the denominator rigorously, follow trajectories after discharge, benchmark testing and outcomes across the state, and, crucially, help distinguish frailty markers from ventilatory targets that can alter risk.</a:t>
-            </a:r>
-          </a:p>
-          <a:p>
-            <a:br>
-              <a:rPr lang="en-US" dirty="0"/>
-            </a:br>
-            <a:endParaRPr lang="en-US" dirty="0"/>
-          </a:p>
-          <a:p>
-            <a:r>
-              <a:rPr lang="en-US" dirty="0"/>
-              <a:t>The usual post‑discharge workflow helps explain low completion rates. An inpatient team prescribes a home mechanical ventilator; the DME company receives the order and sends a respiratory therapist to set up equipment and educate the family; referrals go to PDNs and to pulmonary clinic; PFTs are typically ordered before the pulmonary visit; sleep referrals are placed and often misunderstood by patients who presented with daytime dyspnea. Many steps occur before any specialist discussion, and each step can derail. This argues for two parallel efforts: measure how the system is performing now (CO₂‑PATH) and move toward risk‑based referrals and early empiric management when indicated.</a:t>
-            </a:r>
-          </a:p>
-          <a:p>
-            <a:br>
-              <a:rPr lang="en-US" dirty="0"/>
-            </a:br>
-            <a:endParaRPr lang="en-US" dirty="0"/>
-          </a:p>
-          <a:p>
-            <a:r>
-              <a:rPr lang="en-US" dirty="0"/>
-              <a:t>Based on ICD counts, I estimate 5,000–6,000 hypercapnic respiratory failure cases present to acute care or ED settings within Intermountain annually. Not all require specialty care—some are transient, iatrogenic, or manageable in primary or general pulmonary care—but we need to identify the subset at high risk of readmission if we don’t intervene. AIM‑HIGH, which links Intermountain clinical data with Select Health claims, is designed to stratify that risk and target resources.</a:t>
-            </a:r>
-          </a:p>
-          <a:p>
-            <a:br>
-              <a:rPr lang="en-US" dirty="0"/>
-            </a:br>
-            <a:endParaRPr lang="en-US" dirty="0"/>
-          </a:p>
-          <a:p>
-            <a:r>
-              <a:rPr lang="en-US" dirty="0"/>
-              <a:t>In the Schmidt Clinic, I spend most of my time managing chronic respiratory failure. Our three main referral streams are high‑risk post‑discharge patients via the pulmonary disease navigators (Claire Davies and Megan Hepworth), internal referrals for potential NIV starts, and a neuromuscular clinic. We don’t have an ALS center at Intermountain, so those patients go to the university, but other neuromuscular patients come to our clinic. We could accept more referrals from PM&amp;R, post‑acute facilities, and patients initially triaged to sleep clinics for suspected OHS who are ultimately determined not to have a primary sleep‑breathing disorder. Much of this care can be handled remotely. Device downloads provide rich information; paired with video visits, we can deliver high‑fidelity care and potentially expand our geographic reach.</a:t>
-            </a:r>
-          </a:p>
-          <a:p>
-            <a:br>
-              <a:rPr lang="en-US" dirty="0"/>
-            </a:br>
-            <a:endParaRPr lang="en-US" dirty="0"/>
-          </a:p>
-          <a:p>
-            <a:r>
-              <a:rPr lang="en-US" dirty="0"/>
-              <a:t>To close, I want to clarify device categories and the new coverage rules. “Respiratory assist device” is a term coined when CPAP for sleep apnea and hospital ventilators had distinct roles; CMS wanted to avoid paying for home ventilators for the entire sleep apnea population. The community adopted “RAD” to signal that these were not ventilators. The technology has matured: modern RADs can do bilevel, backup rates, and volume‑assured pressure support (volume‑targeted pressure support). Some capabilities still require a home mechanical ventilator, such as AVAPS‑AE (volume assurance with adjustable EPAP) and other advanced modes used in severe disease. RADs typically cap maximum inspiratory pressures around 30 cm H₂O, which sounds high until you recall that contemporary COPD NIV trials have mean IPAPs in the mid‑20s and about a quarter of patients above 30. RAD settings can be changed remotely; HMV settings generally cannot. RADs are capped‑rental and eventually owned by the patient; HMVs fall under frequent‑and‑substantial‑servicing rental and include bundled respiratory therapy support.</a:t>
-            </a:r>
-          </a:p>
-          <a:p>
-            <a:br>
-              <a:rPr lang="en-US" dirty="0"/>
-            </a:br>
-            <a:endParaRPr lang="en-US" dirty="0"/>
-          </a:p>
-          <a:p>
-            <a:r>
-              <a:rPr lang="en-US" dirty="0"/>
-              <a:t>Historically, RAD qualification pathways were fragmented (restrictive thoracic disorders, hypercapnic COPD, hypoventilation), with requirements that often didn’t match the indication—for example, obligate nocturnal hypoxemia in COPD candidates. CMS recently approved a new national coverage determination. Neuromuscular criteria are unchanged: a qualifying diagnosis plus either hypercapnia, nocturnal hypoxemia, or spirometry criteria. The COPD bucket is now effectively “all chronic respiratory failure,” which is confusing but pragmatic. There are two paths: outpatient and discharge. The outpatient path doesn’t require PFTs; it does require stable daytime </a:t>
-            </a:r>
-            <a:r>
-              <a:rPr lang="en-US" dirty="0" err="1"/>
-              <a:t>PaCO</a:t>
-            </a:r>
-            <a:r>
-              <a:rPr lang="en-US" dirty="0"/>
-              <a:t>₂ ≥52 mmHg and a determination that sleep apnea isn’t the sole cause (not necessarily proven by polysomnography or nocturnal oximetry). The discharge path requires full RAD settings documented within 24 hours of discharge and a clinical judgment that the device is needed to avoid symptoms or rapid CO₂ rise. Both paths now include re‑qualification every six months, including average use of at least five hours per 24 hours and documented improvement in CO₂, exacerbations, or symptoms—which will increase clinic volume and require workflow adjustments.</a:t>
-            </a:r>
-          </a:p>
-          <a:p>
-            <a:br>
-              <a:rPr lang="en-US" dirty="0"/>
-            </a:br>
-            <a:endParaRPr lang="en-US" dirty="0"/>
-          </a:p>
-          <a:p>
-            <a:r>
-              <a:rPr lang="en-US" dirty="0"/>
-              <a:t>HMV previously had an easier bar: a qualifying condition plus a statement that interruption of support would quickly lead to serious harm or death. That disparity helped drive HMV use upward, not always because patients needed ventilators, but because RAD qualification was onerous. Under the updated rules, neuromuscular indications for HMV are unchanged. For non‑neuromuscular chronic respiratory failure, the outpatient path now requires meeting RAD criteria plus at least one additional need (an advanced mode, higher IPAP requirements, or failure of RAD), and in our setting, oxygen needs above roughly 36% (about 4 L/min) can also support the case when combined with one of those criteria. The discharge path hinges on documented inpatient use of the HMV within 24 hours and capabilities that exceed what a RAD can provide, with full settings documented. Ongoing follow‑up requirements align with those for RADs.</a:t>
-            </a:r>
-          </a:p>
-          <a:p>
-            <a:br>
-              <a:rPr lang="en-US" dirty="0"/>
-            </a:br>
-            <a:endParaRPr lang="en-US" dirty="0"/>
-          </a:p>
-          <a:p>
-            <a:r>
-              <a:rPr lang="en-US" dirty="0"/>
-              <a:t>If you’re interested in collaborating on hypercapnia research, have ideas about referrals, or want to discuss specific patients, please reach out in the EHR (soon via Epic) or by email. This is a team effort: our pulmonary disease navigators, Claire Davies and Megan Hepworth, do a tremendous amount of the day‑to‑day work, and our research partners span Intermountain, Select Health, the University of Utah, and UC Davis. I’m happy to take questions.</a:t>
-            </a:r>
-          </a:p>
-          <a:p>
             <a:endParaRPr lang="en-US" dirty="0"/>
           </a:p>
         </p:txBody>
@@ -1308,11 +841,19 @@
           <a:bodyPr/>
           <a:lstStyle/>
           <a:p>
-            <a:pPr marL="171450" indent="-171450">
-              <a:buFontTx/>
-              <a:buChar char="-"/>
-            </a:pPr>
+            <a:r>
+              <a:rPr lang="en-US" dirty="0"/>
+              <a:t>SO WHAT — THE EVIDENCE GAP</a:t>
+            </a:r>
+          </a:p>
+          <a:p>
             <a:endParaRPr lang="en-US" dirty="0"/>
+          </a:p>
+          <a:p>
+            <a:r>
+              <a:rPr lang="en-US" dirty="0"/>
+              <a:t>Current guidelines assume a known etiology. Most patients arrive without one. The result: low rates of diagnostic workup, fragmented post-discharge care, and no systematic framework for identifying who benefits from early intervention.</a:t>
+            </a:r>
           </a:p>
         </p:txBody>
       </p:sp>
@@ -1589,7 +1130,7 @@
           <a:p>
             <a:fld id="{7B5031F0-EA56-3740-A29C-52740243DB2E}" type="datetimeFigureOut">
               <a:rPr lang="en-US" smtClean="0"/>
-              <a:t>3/8/26</a:t>
+              <a:t>3/12/26</a:t>
             </a:fld>
             <a:endParaRPr lang="en-US"/>
           </a:p>
@@ -1787,7 +1328,7 @@
           <a:p>
             <a:fld id="{7B5031F0-EA56-3740-A29C-52740243DB2E}" type="datetimeFigureOut">
               <a:rPr lang="en-US" smtClean="0"/>
-              <a:t>3/8/26</a:t>
+              <a:t>3/12/26</a:t>
             </a:fld>
             <a:endParaRPr lang="en-US"/>
           </a:p>
@@ -1995,7 +1536,7 @@
           <a:p>
             <a:fld id="{7B5031F0-EA56-3740-A29C-52740243DB2E}" type="datetimeFigureOut">
               <a:rPr lang="en-US" smtClean="0"/>
-              <a:t>3/8/26</a:t>
+              <a:t>3/12/26</a:t>
             </a:fld>
             <a:endParaRPr lang="en-US"/>
           </a:p>
@@ -2193,7 +1734,7 @@
           <a:p>
             <a:fld id="{7B5031F0-EA56-3740-A29C-52740243DB2E}" type="datetimeFigureOut">
               <a:rPr lang="en-US" smtClean="0"/>
-              <a:t>3/8/26</a:t>
+              <a:t>3/12/26</a:t>
             </a:fld>
             <a:endParaRPr lang="en-US"/>
           </a:p>
@@ -2468,7 +2009,7 @@
           <a:p>
             <a:fld id="{7B5031F0-EA56-3740-A29C-52740243DB2E}" type="datetimeFigureOut">
               <a:rPr lang="en-US" smtClean="0"/>
-              <a:t>3/8/26</a:t>
+              <a:t>3/12/26</a:t>
             </a:fld>
             <a:endParaRPr lang="en-US"/>
           </a:p>
@@ -2733,7 +2274,7 @@
           <a:p>
             <a:fld id="{7B5031F0-EA56-3740-A29C-52740243DB2E}" type="datetimeFigureOut">
               <a:rPr lang="en-US" smtClean="0"/>
-              <a:t>3/8/26</a:t>
+              <a:t>3/12/26</a:t>
             </a:fld>
             <a:endParaRPr lang="en-US"/>
           </a:p>
@@ -3145,7 +2686,7 @@
           <a:p>
             <a:fld id="{7B5031F0-EA56-3740-A29C-52740243DB2E}" type="datetimeFigureOut">
               <a:rPr lang="en-US" smtClean="0"/>
-              <a:t>3/8/26</a:t>
+              <a:t>3/12/26</a:t>
             </a:fld>
             <a:endParaRPr lang="en-US"/>
           </a:p>
@@ -3286,7 +2827,7 @@
           <a:p>
             <a:fld id="{7B5031F0-EA56-3740-A29C-52740243DB2E}" type="datetimeFigureOut">
               <a:rPr lang="en-US" smtClean="0"/>
-              <a:t>3/8/26</a:t>
+              <a:t>3/12/26</a:t>
             </a:fld>
             <a:endParaRPr lang="en-US"/>
           </a:p>
@@ -3399,7 +2940,7 @@
           <a:p>
             <a:fld id="{7B5031F0-EA56-3740-A29C-52740243DB2E}" type="datetimeFigureOut">
               <a:rPr lang="en-US" smtClean="0"/>
-              <a:t>3/8/26</a:t>
+              <a:t>3/12/26</a:t>
             </a:fld>
             <a:endParaRPr lang="en-US"/>
           </a:p>
@@ -3710,7 +3251,7 @@
           <a:p>
             <a:fld id="{7B5031F0-EA56-3740-A29C-52740243DB2E}" type="datetimeFigureOut">
               <a:rPr lang="en-US" smtClean="0"/>
-              <a:t>3/8/26</a:t>
+              <a:t>3/12/26</a:t>
             </a:fld>
             <a:endParaRPr lang="en-US"/>
           </a:p>
@@ -3998,7 +3539,7 @@
           <a:p>
             <a:fld id="{7B5031F0-EA56-3740-A29C-52740243DB2E}" type="datetimeFigureOut">
               <a:rPr lang="en-US" smtClean="0"/>
-              <a:t>3/8/26</a:t>
+              <a:t>3/12/26</a:t>
             </a:fld>
             <a:endParaRPr lang="en-US"/>
           </a:p>
@@ -4242,7 +3783,7 @@
           <a:p>
             <a:fld id="{7B5031F0-EA56-3740-A29C-52740243DB2E}" type="datetimeFigureOut">
               <a:rPr lang="en-US" smtClean="0"/>
-              <a:t>3/8/26</a:t>
+              <a:t>3/12/26</a:t>
             </a:fld>
             <a:endParaRPr lang="en-US"/>
           </a:p>
@@ -7891,7 +7432,7 @@
     </p:spTree>
     <p:extLst>
       <p:ext uri="{BB962C8B-B14F-4D97-AF65-F5344CB8AC3E}">
-        <p14:creationId xmlns:p14="http://schemas.microsoft.com/office/powerpoint/2010/main" val="2735874719"/>
+        <p14:creationId xmlns:p14="http://schemas.microsoft.com/office/powerpoint/2010/main" val="605175366"/>
       </p:ext>
     </p:extLst>
   </p:cSld>
@@ -12102,10 +11643,10 @@
           <p:nvPr/>
         </p:nvPicPr>
         <p:blipFill>
-          <a:blip r:embed="rId3">
+          <a:blip>
             <a:extLst>
               <a:ext uri="{96DAC541-7B7A-43D3-8B79-37D633B846F1}">
-                <asvg:svgBlip xmlns:asvg="http://schemas.microsoft.com/office/drawing/2016/SVG/main" r:embed="rId4"/>
+                <asvg:svgBlip xmlns:asvg="http://schemas.microsoft.com/office/drawing/2016/SVG/main" r:embed="rId3"/>
               </a:ext>
             </a:extLst>
           </a:blip>
@@ -12138,7 +11679,7 @@
           <p:nvPr/>
         </p:nvPicPr>
         <p:blipFill rotWithShape="1">
-          <a:blip r:embed="rId5" cstate="screen">
+          <a:blip r:embed="rId4" cstate="screen">
             <a:extLst>
               <a:ext uri="{28A0092B-C50C-407E-A947-70E740481C1C}">
                 <a14:useLocalDpi xmlns:a14="http://schemas.microsoft.com/office/drawing/2010/main"/>
@@ -12183,7 +11724,7 @@
           <p:nvPr/>
         </p:nvPicPr>
         <p:blipFill rotWithShape="1">
-          <a:blip r:embed="rId6" cstate="screen">
+          <a:blip r:embed="rId5" cstate="screen">
             <a:extLst>
               <a:ext uri="{28A0092B-C50C-407E-A947-70E740481C1C}">
                 <a14:useLocalDpi xmlns:a14="http://schemas.microsoft.com/office/drawing/2010/main"/>
@@ -12228,7 +11769,7 @@
           <p:nvPr/>
         </p:nvPicPr>
         <p:blipFill>
-          <a:blip r:embed="rId7"/>
+          <a:blip r:embed="rId6"/>
           <a:stretch>
             <a:fillRect/>
           </a:stretch>
@@ -12258,7 +11799,7 @@
           <p:nvPr/>
         </p:nvPicPr>
         <p:blipFill>
-          <a:blip r:embed="rId8"/>
+          <a:blip r:embed="rId7"/>
           <a:stretch>
             <a:fillRect/>
           </a:stretch>

</xml_diff>

<commit_message>
Update archived presentation files
Replace two archived PowerPoint files with updated versions: archive/Presentations/Locke Research Update Mar2026.pptx and archive/Presentations/Locke Utah ACP OHS 2026.pptx. Keeps the archive in sync with the latest presentation edits.
</commit_message>
<xml_diff>
--- a/archive/Presentations/Locke Research Update Mar2026.pptx
+++ b/archive/Presentations/Locke Research Update Mar2026.pptx
@@ -11,8 +11,8 @@
     <p:sldId id="954" r:id="rId2"/>
     <p:sldId id="926" r:id="rId3"/>
     <p:sldId id="933" r:id="rId4"/>
-    <p:sldId id="966" r:id="rId5"/>
-    <p:sldId id="940" r:id="rId6"/>
+    <p:sldId id="940" r:id="rId5"/>
+    <p:sldId id="966" r:id="rId6"/>
     <p:sldId id="876" r:id="rId7"/>
     <p:sldId id="862" r:id="rId8"/>
     <p:sldId id="960" r:id="rId9"/>
@@ -205,7 +205,7 @@
           <a:p>
             <a:fld id="{5743F77F-9A3C-E740-9DB0-E9D6C9A5452C}" type="datetimeFigureOut">
               <a:rPr lang="en-US" smtClean="0"/>
-              <a:t>3/12/26</a:t>
+              <a:t>3/13/26</a:t>
             </a:fld>
             <a:endParaRPr lang="en-US"/>
           </a:p>
@@ -516,6 +516,1082 @@
           <a:bodyPr/>
           <a:lstStyle/>
           <a:p>
+            <a:r>
+              <a:rPr lang="en-US" sz="1200" b="0" i="0" kern="1200" dirty="0">
+                <a:solidFill>
+                  <a:schemeClr val="tx1"/>
+                </a:solidFill>
+                <a:effectLst/>
+                <a:latin typeface="+mn-lt"/>
+                <a:ea typeface="+mn-ea"/>
+                <a:cs typeface="+mn-cs"/>
+              </a:rPr>
+              <a:t>Hi, everyone. My name is Brian Locke. I am going to talk for 10 minutes or so on my research program here at Intermountain. In terms of just hopping in since we don't have a lot of time, I think I've met most folks who are on the call. But for those who I haven't, I'm Brian. I joined Intermountain roughly two years ago. And I have computer science and clinical investigation backgrounds. And I practice in shock trauma and also down in the Schmidt Chest Clinic where I have a subspecialty clinic in chronic respiratory failure. And so it would be folks that need home ventilation or have obesity, hypoventilation syndrome or any other combination. Essentially the population we're going to talk about today. And that my research focuses primarily on trying to better capture data out of the health record to support research on </a:t>
+            </a:r>
+            <a:r>
+              <a:rPr lang="en-US" sz="1200" b="0" i="0" kern="1200" dirty="0" err="1">
+                <a:solidFill>
+                  <a:schemeClr val="tx1"/>
+                </a:solidFill>
+                <a:effectLst/>
+                <a:latin typeface="+mn-lt"/>
+                <a:ea typeface="+mn-ea"/>
+                <a:cs typeface="+mn-cs"/>
+              </a:rPr>
+              <a:t>hypercapmic</a:t>
+            </a:r>
+            <a:r>
+              <a:rPr lang="en-US" sz="1200" b="0" i="0" kern="1200" dirty="0">
+                <a:solidFill>
+                  <a:schemeClr val="tx1"/>
+                </a:solidFill>
+                <a:effectLst/>
+                <a:latin typeface="+mn-lt"/>
+                <a:ea typeface="+mn-ea"/>
+                <a:cs typeface="+mn-cs"/>
+              </a:rPr>
+              <a:t> respiratory failure, which right now is primarily describing the disease burden costs, care processes that are occurring now. Although my hope is to build that up to a program that is testing interventions to improve their care. And so just to jump back to our topic, the scale of the problem. You know, so </a:t>
+            </a:r>
+            <a:r>
+              <a:rPr lang="en-US" sz="1200" b="0" i="0" kern="1200" dirty="0" err="1">
+                <a:solidFill>
+                  <a:schemeClr val="tx1"/>
+                </a:solidFill>
+                <a:effectLst/>
+                <a:latin typeface="+mn-lt"/>
+                <a:ea typeface="+mn-ea"/>
+                <a:cs typeface="+mn-cs"/>
+              </a:rPr>
+              <a:t>hypercapmic</a:t>
+            </a:r>
+            <a:r>
+              <a:rPr lang="en-US" sz="1200" b="0" i="0" kern="1200" dirty="0">
+                <a:solidFill>
+                  <a:schemeClr val="tx1"/>
+                </a:solidFill>
+                <a:effectLst/>
+                <a:latin typeface="+mn-lt"/>
+                <a:ea typeface="+mn-ea"/>
+                <a:cs typeface="+mn-cs"/>
+              </a:rPr>
+              <a:t> respiratory failure has a substantial health burden that actually doesn't receive much attention as an all-cause syndrome. And I'll talk about why I think it should. If we just think about how often </a:t>
+            </a:r>
+            <a:r>
+              <a:rPr lang="en-US" sz="1200" b="0" i="0" kern="1200" dirty="0" err="1">
+                <a:solidFill>
+                  <a:schemeClr val="tx1"/>
+                </a:solidFill>
+                <a:effectLst/>
+                <a:latin typeface="+mn-lt"/>
+                <a:ea typeface="+mn-ea"/>
+                <a:cs typeface="+mn-cs"/>
+              </a:rPr>
+              <a:t>hypercapmic</a:t>
+            </a:r>
+            <a:r>
+              <a:rPr lang="en-US" sz="1200" b="0" i="0" kern="1200" dirty="0">
+                <a:solidFill>
+                  <a:schemeClr val="tx1"/>
+                </a:solidFill>
+                <a:effectLst/>
+                <a:latin typeface="+mn-lt"/>
+                <a:ea typeface="+mn-ea"/>
+                <a:cs typeface="+mn-cs"/>
+              </a:rPr>
+              <a:t> respiratory failure occurs, the best period prevalence estimates put it at somewhere around 150,000, 150 cases per 100,000 people per year. I think that's probably a bit of an underestimate. If you do the math for Utah and we have. Just as a reference, that's probably like double decompensated cirrhosis, which is something else that we take care of a lot in shock trauma. And has a substantial mortality. So 20% in the two months after. And about a quarter of patients are readmitted within 60 days to the hospital, usually with recurrent </a:t>
+            </a:r>
+            <a:r>
+              <a:rPr lang="en-US" sz="1200" b="0" i="0" kern="1200" dirty="0" err="1">
+                <a:solidFill>
+                  <a:schemeClr val="tx1"/>
+                </a:solidFill>
+                <a:effectLst/>
+                <a:latin typeface="+mn-lt"/>
+                <a:ea typeface="+mn-ea"/>
+                <a:cs typeface="+mn-cs"/>
+              </a:rPr>
+              <a:t>hypercapmic</a:t>
+            </a:r>
+            <a:r>
+              <a:rPr lang="en-US" sz="1200" b="0" i="0" kern="1200" dirty="0">
+                <a:solidFill>
+                  <a:schemeClr val="tx1"/>
+                </a:solidFill>
+                <a:effectLst/>
+                <a:latin typeface="+mn-lt"/>
+                <a:ea typeface="+mn-ea"/>
+                <a:cs typeface="+mn-cs"/>
+              </a:rPr>
+              <a:t> respiratory failure. And so if we look in Utah, you know, we find evidence that there is quite substantial diagnostic burden. That, you know, when we looked at the all-payer claims data, you know, we see around 15,000 cases that are diagnosed by ICD code, which is a substantial undercount in Utah. And that more pertinent to us, you know, in the Intermountain Select Health co-insured population. You know, there's about 1,000 cases per year in the Canyons region if you include blood class criteria on there. And that by that criterion, you know, these admissions cost about $50,000 per index hospitalization. So, you know, I think my, you know, can better healthcare delivery improve these outcomes? I think there's a big reason to suspect so. When we look at what currently happens in these patients, you know, it's really only about a third or a quarter or one in five that actually have preexisting diagnoses before they come into the hospital. You know, this is in some ways similar to the decompensated cirrhosis in that it's not usually somebody who's never had lung disease and they come in with </a:t>
+            </a:r>
+            <a:r>
+              <a:rPr lang="en-US" sz="1200" b="0" i="0" kern="1200" dirty="0" err="1">
+                <a:solidFill>
+                  <a:schemeClr val="tx1"/>
+                </a:solidFill>
+                <a:effectLst/>
+                <a:latin typeface="+mn-lt"/>
+                <a:ea typeface="+mn-ea"/>
+                <a:cs typeface="+mn-cs"/>
+              </a:rPr>
+              <a:t>hypercapmic</a:t>
+            </a:r>
+            <a:r>
+              <a:rPr lang="en-US" sz="1200" b="0" i="0" kern="1200" dirty="0">
+                <a:solidFill>
+                  <a:schemeClr val="tx1"/>
+                </a:solidFill>
+                <a:effectLst/>
+                <a:latin typeface="+mn-lt"/>
+                <a:ea typeface="+mn-ea"/>
+                <a:cs typeface="+mn-cs"/>
+              </a:rPr>
+              <a:t> respiratory failure. And, you know, it's a big problem because the clinical practice guidelines that recommend different strategies of care presume that the diagnosis has already been firmly established. When one of these patients comes into the hospital, there are, it's not possible to get all the testing they would need for that diagnosis. For example, sleep testing has to occur as an outpatient. And if we look, this is statewide at how many folks who have an ICD code of </a:t>
+            </a:r>
+            <a:r>
+              <a:rPr lang="en-US" sz="1200" b="0" i="0" kern="1200" dirty="0" err="1">
+                <a:solidFill>
+                  <a:schemeClr val="tx1"/>
+                </a:solidFill>
+                <a:effectLst/>
+                <a:latin typeface="+mn-lt"/>
+                <a:ea typeface="+mn-ea"/>
+                <a:cs typeface="+mn-cs"/>
+              </a:rPr>
+              <a:t>hypercapmic</a:t>
+            </a:r>
+            <a:r>
+              <a:rPr lang="en-US" sz="1200" b="0" i="0" kern="1200" dirty="0">
+                <a:solidFill>
+                  <a:schemeClr val="tx1"/>
+                </a:solidFill>
+                <a:effectLst/>
+                <a:latin typeface="+mn-lt"/>
+                <a:ea typeface="+mn-ea"/>
+                <a:cs typeface="+mn-cs"/>
+              </a:rPr>
+              <a:t> respiratory failure go on to get the correct testing. You know, we see only 15% get pulmonary function testing, 10% get sleep testing. You know, very low. About a third or about a half get echocardiograms. So that's better. And part of the reason is that there is a transfer of care that has to happen between the inpatient teams and the correct specialist, which often the correct specialist isn't known. And so when we think of, you know, what to do here, I think there's a big room for improvement. And so, you know, I mentioned a couple times that the way in which we identify patients matters a lot. And so this is prior work from our group, including Sam and </a:t>
+            </a:r>
+            <a:r>
+              <a:rPr lang="en-US" sz="1200" b="0" i="0" kern="1200" dirty="0" err="1">
+                <a:solidFill>
+                  <a:schemeClr val="tx1"/>
+                </a:solidFill>
+                <a:effectLst/>
+                <a:latin typeface="+mn-lt"/>
+                <a:ea typeface="+mn-ea"/>
+                <a:cs typeface="+mn-cs"/>
+              </a:rPr>
+              <a:t>Ithin</a:t>
+            </a:r>
+            <a:r>
+              <a:rPr lang="en-US" sz="1200" b="0" i="0" kern="1200" dirty="0">
+                <a:solidFill>
+                  <a:schemeClr val="tx1"/>
+                </a:solidFill>
+                <a:effectLst/>
+                <a:latin typeface="+mn-lt"/>
+                <a:ea typeface="+mn-ea"/>
+                <a:cs typeface="+mn-cs"/>
+              </a:rPr>
+              <a:t>, that was published in Chess relatively recently. And one of the key findings is if you just look back through the literature at, you know, what methods people have used to identify patients with </a:t>
+            </a:r>
+            <a:r>
+              <a:rPr lang="en-US" sz="1200" b="0" i="0" kern="1200" dirty="0" err="1">
+                <a:solidFill>
+                  <a:schemeClr val="tx1"/>
+                </a:solidFill>
+                <a:effectLst/>
+                <a:latin typeface="+mn-lt"/>
+                <a:ea typeface="+mn-ea"/>
+                <a:cs typeface="+mn-cs"/>
+              </a:rPr>
+              <a:t>hypercapmic</a:t>
+            </a:r>
+            <a:r>
+              <a:rPr lang="en-US" sz="1200" b="0" i="0" kern="1200" dirty="0">
+                <a:solidFill>
+                  <a:schemeClr val="tx1"/>
+                </a:solidFill>
+                <a:effectLst/>
+                <a:latin typeface="+mn-lt"/>
+                <a:ea typeface="+mn-ea"/>
+                <a:cs typeface="+mn-cs"/>
+              </a:rPr>
+              <a:t> respiratory failure and health record data, you find that the different strategies authors have taken. It selects non-overlapping people. And the main reason for this is that there are different diagnostic tests. So arterial blood gases, venous blood gases are among the main ones, or whether you try to select an even narrower group of patients based on whether they ultimately needed intervention. And that none of those have good sensitivity for the underlying condition in practice. And so companion work that was presented at a machine learning conference is that you can use a variety of diagnostic or a variety of data elements from the health record, such as bicarbonate risk factors, prior diagnoses, and do a decent job of identifying these people, or at least one that's more stable. So, you know, why does it matter? You know, I think that it takes a lot, you know, that we really need a different workflow for how we manage these patients. And so on the clinical side of the research program, I think the clinic both serves a purpose in that I think it addresses a gap in how these patients are managed. But my goal would be to use it to generate evidence. And so as it is right now, as I mentioned, you know, the Schmidt Chest Clinic is set up to care for some of these patients. Right now we're identifying patients primarily by word of mouth and through the inpatient respiratory therapy teams. There's an AVAPS protocol that can sort of lead to my clinic. And so our strategy for the patients involved in that is that the inpatient clinical teams identify them. They talk with our pulmonary disease navigators, who Megan Hepworth is the primary one, and then myself or Gabriel Norton, who's an APP in clinic, often will handle issues that occur in that peri-discharge period. And that, you know, we sort of quarterback the immediate workout, you know, with the goal saying, hey, this care traditionally has been scattered and there hasn't been a clear who owns, you know, say, a patient who doesn't come to get the needed workup. Who is going to be reaching out to them? It's not totally clear. And so the research side of this is supported through the PCCM seed grant. And I've been using that grant for sort of two parallel data streams. You know, one that I called AIM High, which is a collaboration with Select Health. And we have linked Intermountain and Select Health data and that we've looked back using those various case definitions that they talked about earlier. And our goal is to, you know, both characterize the economics of costs and expenditures for this group and also do some sort of risk prediction and stratification. You know, if the question is, say, you know, clearly all patients who have high CO2 in the hospital aren't at comparable risk. And I suspect that there's patterns of both patient characteristics and health system characteristics that can really stratify who it is that's at highest risk. Because those are the people that we really want to identify in practice so that they can, you know, for example, be referred into my clinic. And so this is one where we're cleaning the data right now and hopeful to have results in the next few months. The second pipeline is something that I'm calling the CO2 path cohort, which is using Utah population database data. And that we've linked both or that we've gotten regulatory authorization for both statewide linkage with the Intermountain and U of U projects. And that this might be a substantially bigger cohort. It's going to have less outcome resolution. And that our main aim with this project is more to more in-depth characterize the statewide burden of disease and what current care people are getting. And so I actually have a meeting later today with the Utah population database to go through some data specifications in that we're sort of moving a little bit slower than on the Select Health side, but forward. And these two research projects are in support of a K23 that I'm going to be resubmitting here later this year. And it submitted this last year, kind of right around the time all of the chaos from the Trump administration came through. And talked to a program officer earlier this year who was actually quite enthusiastic about just resubmitting. The three sort of aims are going to be a sort of discharge risk stratification aim that's primarily built on that select health cohort post-management variation characterization that's going to aim to establish what people are currently doing and what could be done. And then to pilot a small nudge, and I think it'll most likely be out of a sort of cohort of people who are potentially eligible nudging a small subset to come to see me in clinic in a more random or risk targeted practice. And so, you know, my hope from those objectives is to, you know, get a bit more experience analyzing sort of variation akin to what Ethan and Elizabeth Monroe have been doing in sepsis. And then more embedded trial design and prospective study experience. And as I mentioned, you know, the hope would be to build this up into a more definitive efficacy pragmatic trial. You know, I think another sort of perilous stream that may not go through the NIH, but maybe a separate grant to write for a different funder is that, you know, obesity is a major risk factor here. And that most patients with hypercapnic respiratory failure already have an FD designation. And so GLP-1 efficacy in the group is a major unanswered question. And so I think that would be, you know, one other stream that I'm looking through. You know, and that my goal is to sort of continue to become a technologist and methodologist in those spaces. So with all of that, I'll sort of end there and sort of give thanks to the different groups that have supported this and the data team who I've mentioned a couple and there are more. But that, yeah, with that, I'd be happy to take any questions.</a:t>
+            </a:r>
+          </a:p>
+          <a:p>
+            <a:endParaRPr lang="en-US" sz="1200" b="0" i="0" kern="1200" dirty="0">
+              <a:solidFill>
+                <a:schemeClr val="tx1"/>
+              </a:solidFill>
+              <a:effectLst/>
+              <a:latin typeface="+mn-lt"/>
+              <a:ea typeface="+mn-ea"/>
+              <a:cs typeface="+mn-cs"/>
+            </a:endParaRPr>
+          </a:p>
+          <a:p>
+            <a:endParaRPr lang="en-US" sz="1200" b="0" i="0" kern="1200" dirty="0">
+              <a:solidFill>
+                <a:schemeClr val="tx1"/>
+              </a:solidFill>
+              <a:effectLst/>
+              <a:latin typeface="+mn-lt"/>
+              <a:ea typeface="+mn-ea"/>
+              <a:cs typeface="+mn-cs"/>
+            </a:endParaRPr>
+          </a:p>
+          <a:p>
+            <a:endParaRPr lang="en-US" sz="1200" b="0" i="0" kern="1200" dirty="0">
+              <a:solidFill>
+                <a:schemeClr val="tx1"/>
+              </a:solidFill>
+              <a:effectLst/>
+              <a:latin typeface="+mn-lt"/>
+              <a:ea typeface="+mn-ea"/>
+              <a:cs typeface="+mn-cs"/>
+            </a:endParaRPr>
+          </a:p>
+          <a:p>
+            <a:r>
+              <a:rPr lang="en-US" sz="1200" b="1" i="0" kern="1200" dirty="0">
+                <a:solidFill>
+                  <a:schemeClr val="tx1"/>
+                </a:solidFill>
+                <a:effectLst/>
+                <a:latin typeface="+mn-lt"/>
+                <a:ea typeface="+mn-ea"/>
+                <a:cs typeface="+mn-cs"/>
+              </a:rPr>
+              <a:t>FORMATTED TALK — Slide 1 (Title / Introduction)</a:t>
+            </a:r>
+            <a:endParaRPr lang="en-US" sz="1200" b="0" i="0" kern="1200" dirty="0">
+              <a:solidFill>
+                <a:schemeClr val="tx1"/>
+              </a:solidFill>
+              <a:effectLst/>
+              <a:latin typeface="+mn-lt"/>
+              <a:ea typeface="+mn-ea"/>
+              <a:cs typeface="+mn-cs"/>
+            </a:endParaRPr>
+          </a:p>
+          <a:p>
+            <a:r>
+              <a:rPr lang="en-US" sz="1200" b="0" i="1" kern="1200" dirty="0">
+                <a:solidFill>
+                  <a:schemeClr val="tx1"/>
+                </a:solidFill>
+                <a:effectLst/>
+                <a:latin typeface="+mn-lt"/>
+                <a:ea typeface="+mn-ea"/>
+                <a:cs typeface="+mn-cs"/>
+              </a:rPr>
+              <a:t>Hi, everyone. My name is Brian Locke. I'm going to talk for about ten minutes on my research program here at Intermountain.</a:t>
+            </a:r>
+          </a:p>
+          <a:p>
+            <a:r>
+              <a:rPr lang="en-US" sz="1200" b="0" i="1" kern="1200" dirty="0">
+                <a:solidFill>
+                  <a:schemeClr val="tx1"/>
+                </a:solidFill>
+                <a:effectLst/>
+                <a:latin typeface="+mn-lt"/>
+                <a:ea typeface="+mn-ea"/>
+                <a:cs typeface="+mn-cs"/>
+              </a:rPr>
+              <a:t>In terms of jumping in — since we don't have a lot of time — I think I've met most folks on the call, but for those I haven't: I'm Brian. I joined Intermountain roughly two years ago. I have backgrounds in computer science and clinical investigation. I practice in the Shock Trauma ICU and also down in the Schmidt Chest Clinic, where I have a subspecialty clinic in chronic respiratory failure — so patients who need home ventilation, have obesity hypoventilation syndrome, or any other combination. Essentially, the population we're going to talk about today.</a:t>
+            </a:r>
+          </a:p>
+          <a:p>
+            <a:r>
+              <a:rPr lang="en-US" sz="1200" b="0" i="1" kern="1200" dirty="0">
+                <a:solidFill>
+                  <a:schemeClr val="tx1"/>
+                </a:solidFill>
+                <a:effectLst/>
+                <a:latin typeface="+mn-lt"/>
+                <a:ea typeface="+mn-ea"/>
+                <a:cs typeface="+mn-cs"/>
+              </a:rPr>
+              <a:t>My research focuses primarily on trying to better capture data out of the health record to support research on hypercapnic respiratory failure, which right now primarily means describing the disease burden, costs, and care processes that are occurring. Although my hope is to build that up into a program that tests interventions to improve their care.</a:t>
+            </a:r>
+          </a:p>
+          <a:p>
+            <a:r>
+              <a:rPr lang="en-US" sz="1200" b="0" i="1" kern="1200" dirty="0">
+                <a:solidFill>
+                  <a:schemeClr val="tx1"/>
+                </a:solidFill>
+                <a:effectLst/>
+                <a:latin typeface="+mn-lt"/>
+                <a:ea typeface="+mn-ea"/>
+                <a:cs typeface="+mn-cs"/>
+              </a:rPr>
+              <a:t>So, just to jump to our topic — the scale of the problem. Hypercapnic respiratory failure has a substantial health burden that actually doesn't receive much attention as an all-cause syndrome, and I'll talk about why I think it should. If we think about how often hypercapnic respiratory failure occurs, the best period prevalence estimates put it at somewhere around 150 cases per 100,000 people per year — and I think that's probably a bit of an underestimate. Just as a reference, that's probably about double the rate of decompensated cirrhosis, which is something we also take care of a lot in Shock Trauma. It carries substantial mortality — about 20% in the two months after. And about a quarter of patients are readmitted within 60 days, usually with recurrent hypercapnic respiratory failure.</a:t>
+            </a:r>
+          </a:p>
+          <a:p>
+            <a:r>
+              <a:rPr lang="en-US" sz="1200" b="0" i="1" kern="1200" dirty="0">
+                <a:solidFill>
+                  <a:schemeClr val="tx1"/>
+                </a:solidFill>
+                <a:effectLst/>
+                <a:latin typeface="+mn-lt"/>
+                <a:ea typeface="+mn-ea"/>
+                <a:cs typeface="+mn-cs"/>
+              </a:rPr>
+              <a:t>If we look in Utah, we find evidence that there is quite substantial diagnostic burden. When we looked at the all-payer claims data, we see around 15,000 cases diagnosed by ICD code, which is a substantial undercount in Utah. More pertinent to us, in the Intermountain–Select Health co-insured population, there are about 1,000 cases per year in the Canyons region if you include blood gas criteria. And by that criterion, these admissions cost about $50,000 per index hospitalization.</a:t>
+            </a:r>
+          </a:p>
+          <a:p>
+            <a:r>
+              <a:rPr lang="en-US" sz="1200" b="0" i="1" kern="1200" dirty="0">
+                <a:solidFill>
+                  <a:schemeClr val="tx1"/>
+                </a:solidFill>
+                <a:effectLst/>
+                <a:latin typeface="+mn-lt"/>
+                <a:ea typeface="+mn-ea"/>
+                <a:cs typeface="+mn-cs"/>
+              </a:rPr>
+              <a:t>So — can better healthcare delivery improve these outcomes? I think there's a big reason to suspect so. When we look at what currently happens with these patients, it's really only about a third — or a quarter, or one in five — who actually have preexisting diagnoses before they come into the hospital. In some ways it's similar to decompensated cirrhosis, in that it's not usually somebody who's never had lung disease. But it's a big problem because the clinical practice guidelines that recommend different strategies of care presume that the diagnosis has already been firmly established. When one of these patients comes into the hospital, it's not possible to get all the testing they would need for that diagnosis — for example, sleep testing has to occur as an outpatient.</a:t>
+            </a:r>
+          </a:p>
+          <a:p>
+            <a:r>
+              <a:rPr lang="en-US" sz="1200" b="0" i="1" kern="1200" dirty="0">
+                <a:solidFill>
+                  <a:schemeClr val="tx1"/>
+                </a:solidFill>
+                <a:effectLst/>
+                <a:latin typeface="+mn-lt"/>
+                <a:ea typeface="+mn-ea"/>
+                <a:cs typeface="+mn-cs"/>
+              </a:rPr>
+              <a:t>If we look statewide at how many people who have an ICD code for hypercapnic respiratory failure go on to get the correct testing, we see only 15% get pulmonary function testing, 10% get sleep testing — very low. About a half get echocardiograms, so that's better. Part of the reason is that there's a transfer of care that has to happen between the inpatient teams and the correct specialist, and often the correct specialist isn't known. So when we think about what to do here, I think there's significant room for improvement.</a:t>
+            </a:r>
+          </a:p>
+          <a:p>
+            <a:r>
+              <a:rPr lang="en-US" sz="1200" b="0" i="1" kern="1200" dirty="0">
+                <a:solidFill>
+                  <a:schemeClr val="tx1"/>
+                </a:solidFill>
+                <a:effectLst/>
+                <a:latin typeface="+mn-lt"/>
+                <a:ea typeface="+mn-ea"/>
+                <a:cs typeface="+mn-cs"/>
+              </a:rPr>
+              <a:t>I mentioned a couple of times that the way we identify patients matters a lot. This is prior work from our group, including Sam and Ithan, that was published in CHEST relatively recently. One of the key findings is that if you look through the literature at what methods people have used to identify patients with hypercapnic respiratory failure in health record data, the different strategies select non-overlapping people. The main reason is that the different diagnostic tests — arterial blood gases, venous blood gases — or whether you try to select an even narrower group based on whether they ultimately needed intervention — none of those have good sensitivity for the underlying condition in practice.</a:t>
+            </a:r>
+          </a:p>
+          <a:p>
+            <a:r>
+              <a:rPr lang="en-US" sz="1200" b="0" i="1" kern="1200" dirty="0">
+                <a:solidFill>
+                  <a:schemeClr val="tx1"/>
+                </a:solidFill>
+                <a:effectLst/>
+                <a:latin typeface="+mn-lt"/>
+                <a:ea typeface="+mn-ea"/>
+                <a:cs typeface="+mn-cs"/>
+              </a:rPr>
+              <a:t>Companion work presented at a machine learning conference showed that you can use a variety of data elements from the health record — bicarbonate, risk factors, prior diagnoses — and do a decent job of identifying these people, or at least a more stable job.</a:t>
+            </a:r>
+          </a:p>
+          <a:p>
+            <a:r>
+              <a:rPr lang="en-US" sz="1200" b="0" i="1" kern="1200" dirty="0">
+                <a:solidFill>
+                  <a:schemeClr val="tx1"/>
+                </a:solidFill>
+                <a:effectLst/>
+                <a:latin typeface="+mn-lt"/>
+                <a:ea typeface="+mn-ea"/>
+                <a:cs typeface="+mn-cs"/>
+              </a:rPr>
+              <a:t>So why does it matter? We really need a different workflow for how we manage these patients. On the clinical side of the research program, the clinic serves a dual purpose: it addresses a gap in how these patients are managed, but my goal would also be to use it to generate evidence. Right now, the Schmidt Chest Clinic is set up to care for some of these patients. We're identifying patients primarily by word of mouth and through the inpatient respiratory therapy teams. There's an AVAPS protocol that can lead to my clinic. The strategy is that the inpatient clinical teams identify patients, they talk with our pulmonary disease navigators — Megan Hepworth is the primary one — and then myself or Gabriel Norton, an APP in clinic, handle issues that occur in that peri-discharge period. We quarterback the immediate workup with the goal of saying: this care has traditionally been scattered, and there hasn't been clear ownership of, say, a patient who doesn't come to get the needed workup. Who's going to reach out to them? That hasn't been totally clear.</a:t>
+            </a:r>
+          </a:p>
+          <a:p>
+            <a:r>
+              <a:rPr lang="en-US" sz="1200" b="0" i="1" kern="1200" dirty="0">
+                <a:solidFill>
+                  <a:schemeClr val="tx1"/>
+                </a:solidFill>
+                <a:effectLst/>
+                <a:latin typeface="+mn-lt"/>
+                <a:ea typeface="+mn-ea"/>
+                <a:cs typeface="+mn-cs"/>
+              </a:rPr>
+              <a:t>The research side is supported through the PCCM seed grant, and I've been using that for two parallel data streams. One I call AIM-High, which is a collaboration with Select Health. We've linked Intermountain and Select Health data, and we've looked back using those various case definitions I talked about earlier. Our goal is to characterize the economics — costs and expenditures — for this group and also do some risk prediction and stratification. Clearly, not all patients who have high CO₂ in the hospital are at comparable risk. I suspect there are patterns of both patient characteristics and health system characteristics that can stratify who's at highest risk — because those are the people we want to identify in practice so they can, for example, be referred into my clinic. We're cleaning the data right now and hopeful to have results in the next few months.</a:t>
+            </a:r>
+          </a:p>
+          <a:p>
+            <a:r>
+              <a:rPr lang="en-US" sz="1200" b="0" i="1" kern="1200" dirty="0">
+                <a:solidFill>
+                  <a:schemeClr val="tx1"/>
+                </a:solidFill>
+                <a:effectLst/>
+                <a:latin typeface="+mn-lt"/>
+                <a:ea typeface="+mn-ea"/>
+                <a:cs typeface="+mn-cs"/>
+              </a:rPr>
+              <a:t>The second pipeline is the CO₂-PATH Cohort, which uses Utah Population Database data. We've gotten regulatory authorization for statewide linkage with both the Intermountain and University of Utah data. This will be a substantially bigger cohort but with less outcome resolution. Our main aim is to more deeply characterize the statewide burden of disease and what care people are currently getting. I actually have a meeting later today with the Utah Population Database to go through some data specifications. We're moving a bit slower than on the Select Health side, but moving forward.</a:t>
+            </a:r>
+          </a:p>
+          <a:p>
+            <a:r>
+              <a:rPr lang="en-US" sz="1200" b="0" i="1" kern="1200" dirty="0">
+                <a:solidFill>
+                  <a:schemeClr val="tx1"/>
+                </a:solidFill>
+                <a:effectLst/>
+                <a:latin typeface="+mn-lt"/>
+                <a:ea typeface="+mn-ea"/>
+                <a:cs typeface="+mn-cs"/>
+              </a:rPr>
+              <a:t>These two research projects are in support of a K23 that I'm going to be resubmitting later this year. It submitted last year, right around the time all of the chaos from the administration transition came through. I talked to a program officer earlier this year who was actually quite enthusiastic about just resubmitting. The three aims are: a discharge risk stratification aim primarily built on the Select Health cohort; a post-discharge management variation characterization aimed at establishing what people are currently doing and what could be done; and then to pilot a small nudge — I think it'll most likely be nudging a subset of potentially eligible patients to come see me in clinic in a more randomized or risk-targeted fashion.</a:t>
+            </a:r>
+          </a:p>
+          <a:p>
+            <a:r>
+              <a:rPr lang="en-US" sz="1200" b="0" i="1" kern="1200" dirty="0">
+                <a:solidFill>
+                  <a:schemeClr val="tx1"/>
+                </a:solidFill>
+                <a:effectLst/>
+                <a:latin typeface="+mn-lt"/>
+                <a:ea typeface="+mn-ea"/>
+                <a:cs typeface="+mn-cs"/>
+              </a:rPr>
+              <a:t>My hope from those objectives is to get more experience analyzing variation, akin to what Ethan and Elizabeth Monroe have been doing in sepsis, and then more embedded trial design and prospective study experience. The hope would be to build this up into a more definitive efficacy pragmatic trial.</a:t>
+            </a:r>
+          </a:p>
+          <a:p>
+            <a:r>
+              <a:rPr lang="en-US" sz="1200" b="0" i="1" kern="1200" dirty="0">
+                <a:solidFill>
+                  <a:schemeClr val="tx1"/>
+                </a:solidFill>
+                <a:effectLst/>
+                <a:latin typeface="+mn-lt"/>
+                <a:ea typeface="+mn-ea"/>
+                <a:cs typeface="+mn-cs"/>
+              </a:rPr>
+              <a:t>Another parallel stream that may not go through the NIH — maybe a separate grant for a different funder — is that obesity is a major risk factor here, and most patients with hypercapnic respiratory failure already have an FD designation. So GLP-1 efficacy in this group is a major unanswered question, and I think that's another stream I'm looking into. My goal is to continue to develop as a technologist and methodologist in those spaces.</a:t>
+            </a:r>
+          </a:p>
+          <a:p>
+            <a:r>
+              <a:rPr lang="en-US" sz="1200" b="0" i="1" kern="1200" dirty="0">
+                <a:solidFill>
+                  <a:schemeClr val="tx1"/>
+                </a:solidFill>
+                <a:effectLst/>
+                <a:latin typeface="+mn-lt"/>
+                <a:ea typeface="+mn-ea"/>
+                <a:cs typeface="+mn-cs"/>
+              </a:rPr>
+              <a:t>So with all of that, I'll end there and give thanks to the different groups that have supported this and the data team, some of whom I've mentioned and there are more. With that, I'd be happy to take any questions.</a:t>
+            </a:r>
+          </a:p>
+          <a:p>
+            <a:br>
+              <a:rPr lang="en-US" dirty="0"/>
+            </a:br>
+            <a:endParaRPr lang="en-US" dirty="0"/>
+          </a:p>
+          <a:p>
+            <a:r>
+              <a:rPr lang="en-US" sz="1200" b="1" i="0" kern="1200" dirty="0">
+                <a:solidFill>
+                  <a:schemeClr val="tx1"/>
+                </a:solidFill>
+                <a:effectLst/>
+                <a:latin typeface="+mn-lt"/>
+                <a:ea typeface="+mn-ea"/>
+                <a:cs typeface="+mn-cs"/>
+              </a:rPr>
+              <a:t>Feedback</a:t>
+            </a:r>
+          </a:p>
+          <a:p>
+            <a:r>
+              <a:rPr lang="en-US" sz="1200" b="1" i="0" kern="1200" dirty="0">
+                <a:solidFill>
+                  <a:schemeClr val="tx1"/>
+                </a:solidFill>
+                <a:effectLst/>
+                <a:latin typeface="+mn-lt"/>
+                <a:ea typeface="+mn-ea"/>
+                <a:cs typeface="+mn-cs"/>
+              </a:rPr>
+              <a:t>Overall Impression:</a:t>
+            </a:r>
+            <a:r>
+              <a:rPr lang="en-US" sz="1200" b="0" i="0" kern="1200" dirty="0">
+                <a:solidFill>
+                  <a:schemeClr val="tx1"/>
+                </a:solidFill>
+                <a:effectLst/>
+                <a:latin typeface="+mn-lt"/>
+                <a:ea typeface="+mn-ea"/>
+                <a:cs typeface="+mn-cs"/>
+              </a:rPr>
+              <a:t> This is a strong, well-organized 10-minute research overview. You clearly communicate the clinical problem, your unique position to address it, and a credible roadmap from descriptive work → K23 → pragmatic trial. The audience (Research Leadership Team) should come away understanding both the significance and your trajectory. A few notes:</a:t>
+            </a:r>
+          </a:p>
+          <a:p>
+            <a:r>
+              <a:rPr lang="en-US" sz="1200" b="1" i="0" kern="1200" dirty="0">
+                <a:solidFill>
+                  <a:schemeClr val="tx1"/>
+                </a:solidFill>
+                <a:effectLst/>
+                <a:latin typeface="+mn-lt"/>
+                <a:ea typeface="+mn-ea"/>
+                <a:cs typeface="+mn-cs"/>
+              </a:rPr>
+              <a:t>Strengths</a:t>
+            </a:r>
+          </a:p>
+          <a:p>
+            <a:r>
+              <a:rPr lang="en-US" sz="1200" b="1" i="0" kern="1200" dirty="0">
+                <a:solidFill>
+                  <a:schemeClr val="tx1"/>
+                </a:solidFill>
+                <a:effectLst/>
+                <a:latin typeface="+mn-lt"/>
+                <a:ea typeface="+mn-ea"/>
+                <a:cs typeface="+mn-cs"/>
+              </a:rPr>
+              <a:t>Compelling problem framing.</a:t>
+            </a:r>
+            <a:r>
+              <a:rPr lang="en-US" sz="1200" b="0" i="0" kern="1200" dirty="0">
+                <a:solidFill>
+                  <a:schemeClr val="tx1"/>
+                </a:solidFill>
+                <a:effectLst/>
+                <a:latin typeface="+mn-lt"/>
+                <a:ea typeface="+mn-ea"/>
+                <a:cs typeface="+mn-cs"/>
+              </a:rPr>
+              <a:t> The cirrhosis comparison is an excellent anchor — it instantly conveys severity to an audience of clinical researchers. The cost figure ($50K/admission) and readmission rate (25% at 60 days) land well.</a:t>
+            </a:r>
+          </a:p>
+          <a:p>
+            <a:r>
+              <a:rPr lang="en-US" sz="1200" b="1" i="0" kern="1200" dirty="0">
+                <a:solidFill>
+                  <a:schemeClr val="tx1"/>
+                </a:solidFill>
+                <a:effectLst/>
+                <a:latin typeface="+mn-lt"/>
+                <a:ea typeface="+mn-ea"/>
+                <a:cs typeface="+mn-cs"/>
+              </a:rPr>
+              <a:t>Clear research architecture.</a:t>
+            </a:r>
+            <a:r>
+              <a:rPr lang="en-US" sz="1200" b="0" i="0" kern="1200" dirty="0">
+                <a:solidFill>
+                  <a:schemeClr val="tx1"/>
+                </a:solidFill>
+                <a:effectLst/>
+                <a:latin typeface="+mn-lt"/>
+                <a:ea typeface="+mn-ea"/>
+                <a:cs typeface="+mn-cs"/>
+              </a:rPr>
+              <a:t> The two-pipeline structure (AIM-High with Select Health + CO₂-PATH with UPDB) is easy to follow and shows thoughtful study design with complementary strengths (depth vs. breadth).</a:t>
+            </a:r>
+          </a:p>
+          <a:p>
+            <a:r>
+              <a:rPr lang="en-US" sz="1200" b="1" i="0" kern="1200" dirty="0">
+                <a:solidFill>
+                  <a:schemeClr val="tx1"/>
+                </a:solidFill>
+                <a:effectLst/>
+                <a:latin typeface="+mn-lt"/>
+                <a:ea typeface="+mn-ea"/>
+                <a:cs typeface="+mn-cs"/>
+              </a:rPr>
+              <a:t>Honest about the knowledge </a:t>
+            </a:r>
+            <a:r>
+              <a:rPr lang="en-US" sz="1200" b="1" i="0" kern="1200" dirty="0" err="1">
+                <a:solidFill>
+                  <a:schemeClr val="tx1"/>
+                </a:solidFill>
+                <a:effectLst/>
+                <a:latin typeface="+mn-lt"/>
+                <a:ea typeface="+mn-ea"/>
+                <a:cs typeface="+mn-cs"/>
+              </a:rPr>
+              <a:t>gap.</a:t>
+            </a:r>
+            <a:r>
+              <a:rPr lang="en-US" sz="1200" b="0" i="0" kern="1200" dirty="0" err="1">
+                <a:solidFill>
+                  <a:schemeClr val="tx1"/>
+                </a:solidFill>
+                <a:effectLst/>
+                <a:latin typeface="+mn-lt"/>
+                <a:ea typeface="+mn-ea"/>
+                <a:cs typeface="+mn-cs"/>
+              </a:rPr>
+              <a:t>Citing</a:t>
+            </a:r>
+            <a:r>
+              <a:rPr lang="en-US" sz="1200" b="0" i="0" kern="1200" dirty="0">
+                <a:solidFill>
+                  <a:schemeClr val="tx1"/>
+                </a:solidFill>
+                <a:effectLst/>
+                <a:latin typeface="+mn-lt"/>
+                <a:ea typeface="+mn-ea"/>
+                <a:cs typeface="+mn-cs"/>
+              </a:rPr>
+              <a:t> the non-overlapping case definitions and low diagnostic testing rates (15% PFTs, 10% sleep) is powerful evidence that the field needs your work.</a:t>
+            </a:r>
+          </a:p>
+          <a:p>
+            <a:r>
+              <a:rPr lang="en-US" sz="1200" b="1" i="0" kern="1200" dirty="0">
+                <a:solidFill>
+                  <a:schemeClr val="tx1"/>
+                </a:solidFill>
+                <a:effectLst/>
+                <a:latin typeface="+mn-lt"/>
+                <a:ea typeface="+mn-ea"/>
+                <a:cs typeface="+mn-cs"/>
+              </a:rPr>
+              <a:t>Clinical-research integration.</a:t>
+            </a:r>
+            <a:r>
+              <a:rPr lang="en-US" sz="1200" b="0" i="0" kern="1200" dirty="0">
+                <a:solidFill>
+                  <a:schemeClr val="tx1"/>
+                </a:solidFill>
+                <a:effectLst/>
+                <a:latin typeface="+mn-lt"/>
+                <a:ea typeface="+mn-ea"/>
+                <a:cs typeface="+mn-cs"/>
+              </a:rPr>
+              <a:t> Framing the Schmidt Chest Clinic as both a clinical service and a research vehicle is smart for this audience.</a:t>
+            </a:r>
+          </a:p>
+          <a:p>
+            <a:r>
+              <a:rPr lang="en-US" sz="1200" b="1" i="0" kern="1200" dirty="0">
+                <a:solidFill>
+                  <a:schemeClr val="tx1"/>
+                </a:solidFill>
+                <a:effectLst/>
+                <a:latin typeface="+mn-lt"/>
+                <a:ea typeface="+mn-ea"/>
+                <a:cs typeface="+mn-cs"/>
+              </a:rPr>
+              <a:t>Areas to Tighten</a:t>
+            </a:r>
+          </a:p>
+          <a:p>
+            <a:r>
+              <a:rPr lang="en-US" sz="1200" b="1" i="0" kern="1200" dirty="0">
+                <a:solidFill>
+                  <a:schemeClr val="tx1"/>
+                </a:solidFill>
+                <a:effectLst/>
+                <a:latin typeface="+mn-lt"/>
+                <a:ea typeface="+mn-ea"/>
+                <a:cs typeface="+mn-cs"/>
+              </a:rPr>
+              <a:t>The opening runs long before the "hook."</a:t>
+            </a:r>
+            <a:r>
+              <a:rPr lang="en-US" sz="1200" b="0" i="0" kern="1200" dirty="0">
+                <a:solidFill>
+                  <a:schemeClr val="tx1"/>
+                </a:solidFill>
+                <a:effectLst/>
+                <a:latin typeface="+mn-lt"/>
+                <a:ea typeface="+mn-ea"/>
+                <a:cs typeface="+mn-cs"/>
+              </a:rPr>
+              <a:t> You spend roughly 90 seconds on introductions and background before you get to the scale of the problem. For a 10-minute talk, consider trimming the intro to ~30 seconds ("I'm Brian Locke, I joined two years ago, I practice in Shock Trauma and the Schmidt Chest Clinic in chronic respiratory failure") and getting to the 150/100K prevalence faster. The audience already received your title slide — trust it.</a:t>
+            </a:r>
+          </a:p>
+          <a:p>
+            <a:r>
+              <a:rPr lang="en-US" sz="1200" b="1" i="0" kern="1200" dirty="0">
+                <a:solidFill>
+                  <a:schemeClr val="tx1"/>
+                </a:solidFill>
+                <a:effectLst/>
+                <a:latin typeface="+mn-lt"/>
+                <a:ea typeface="+mn-ea"/>
+                <a:cs typeface="+mn-cs"/>
+              </a:rPr>
+              <a:t>The diagnostic gap section </a:t>
+            </a:r>
+            <a:r>
+              <a:rPr lang="en-US" sz="1200" b="1" i="0" kern="1200" dirty="0" err="1">
+                <a:solidFill>
+                  <a:schemeClr val="tx1"/>
+                </a:solidFill>
+                <a:effectLst/>
+                <a:latin typeface="+mn-lt"/>
+                <a:ea typeface="+mn-ea"/>
+                <a:cs typeface="+mn-cs"/>
+              </a:rPr>
+              <a:t>meanders.</a:t>
+            </a:r>
+            <a:r>
+              <a:rPr lang="en-US" sz="1200" b="0" i="0" kern="1200" dirty="0" err="1">
+                <a:solidFill>
+                  <a:schemeClr val="tx1"/>
+                </a:solidFill>
+                <a:effectLst/>
+                <a:latin typeface="+mn-lt"/>
+                <a:ea typeface="+mn-ea"/>
+                <a:cs typeface="+mn-cs"/>
+              </a:rPr>
+              <a:t>You</a:t>
+            </a:r>
+            <a:r>
+              <a:rPr lang="en-US" sz="1200" b="0" i="0" kern="1200" dirty="0">
+                <a:solidFill>
+                  <a:schemeClr val="tx1"/>
+                </a:solidFill>
+                <a:effectLst/>
+                <a:latin typeface="+mn-lt"/>
+                <a:ea typeface="+mn-ea"/>
+                <a:cs typeface="+mn-cs"/>
+              </a:rPr>
+              <a:t> make the critical point — patients aren't getting tested — but then immediately pivot to the case definition problem. Consider separating these clearly: (a) </a:t>
+            </a:r>
+            <a:r>
+              <a:rPr lang="en-US" sz="1200" b="0" i="1" kern="1200" dirty="0">
+                <a:solidFill>
+                  <a:schemeClr val="tx1"/>
+                </a:solidFill>
+                <a:effectLst/>
+                <a:latin typeface="+mn-lt"/>
+                <a:ea typeface="+mn-ea"/>
+                <a:cs typeface="+mn-cs"/>
+              </a:rPr>
+              <a:t>"Patients aren't getting diagnosed or worked up"</a:t>
+            </a:r>
+            <a:r>
+              <a:rPr lang="en-US" sz="1200" b="0" i="0" kern="1200" dirty="0">
+                <a:solidFill>
+                  <a:schemeClr val="tx1"/>
+                </a:solidFill>
+                <a:effectLst/>
+                <a:latin typeface="+mn-lt"/>
+                <a:ea typeface="+mn-ea"/>
+                <a:cs typeface="+mn-cs"/>
+              </a:rPr>
+              <a:t> → data on low testing rates; (b) </a:t>
+            </a:r>
+            <a:r>
+              <a:rPr lang="en-US" sz="1200" b="0" i="1" kern="1200" dirty="0">
+                <a:solidFill>
+                  <a:schemeClr val="tx1"/>
+                </a:solidFill>
+                <a:effectLst/>
+                <a:latin typeface="+mn-lt"/>
+                <a:ea typeface="+mn-ea"/>
+                <a:cs typeface="+mn-cs"/>
+              </a:rPr>
+              <a:t>"And even in research, we can't agree on who these patients are"</a:t>
+            </a:r>
+            <a:r>
+              <a:rPr lang="en-US" sz="1200" b="0" i="0" kern="1200" dirty="0">
+                <a:solidFill>
+                  <a:schemeClr val="tx1"/>
+                </a:solidFill>
+                <a:effectLst/>
+                <a:latin typeface="+mn-lt"/>
+                <a:ea typeface="+mn-ea"/>
+                <a:cs typeface="+mn-cs"/>
+              </a:rPr>
+              <a:t> → the CHEST paper. Right now they blend together and dilute each other.</a:t>
+            </a:r>
+          </a:p>
+          <a:p>
+            <a:r>
+              <a:rPr lang="en-US" sz="1200" b="1" i="0" kern="1200" dirty="0">
+                <a:solidFill>
+                  <a:schemeClr val="tx1"/>
+                </a:solidFill>
+                <a:effectLst/>
+                <a:latin typeface="+mn-lt"/>
+                <a:ea typeface="+mn-ea"/>
+                <a:cs typeface="+mn-cs"/>
+              </a:rPr>
+              <a:t>Verbal hedging dilutes </a:t>
+            </a:r>
+            <a:r>
+              <a:rPr lang="en-US" sz="1200" b="1" i="0" kern="1200" dirty="0" err="1">
+                <a:solidFill>
+                  <a:schemeClr val="tx1"/>
+                </a:solidFill>
+                <a:effectLst/>
+                <a:latin typeface="+mn-lt"/>
+                <a:ea typeface="+mn-ea"/>
+                <a:cs typeface="+mn-cs"/>
+              </a:rPr>
+              <a:t>authority.</a:t>
+            </a:r>
+            <a:r>
+              <a:rPr lang="en-US" sz="1200" b="0" i="0" kern="1200" dirty="0" err="1">
+                <a:solidFill>
+                  <a:schemeClr val="tx1"/>
+                </a:solidFill>
+                <a:effectLst/>
+                <a:latin typeface="+mn-lt"/>
+                <a:ea typeface="+mn-ea"/>
+                <a:cs typeface="+mn-cs"/>
+              </a:rPr>
+              <a:t>Phrases</a:t>
+            </a:r>
+            <a:r>
+              <a:rPr lang="en-US" sz="1200" b="0" i="0" kern="1200" dirty="0">
+                <a:solidFill>
+                  <a:schemeClr val="tx1"/>
+                </a:solidFill>
+                <a:effectLst/>
+                <a:latin typeface="+mn-lt"/>
+                <a:ea typeface="+mn-ea"/>
+                <a:cs typeface="+mn-cs"/>
+              </a:rPr>
+              <a:t> like "I think probably," "you know," "sort of," "a bit of" appear frequently. A few are natural and human — but in a 10-minute slot, they add up. The most impactful statements in your talk are the direct ones ("These admissions cost $50,000 per index hospitalization"). Try to match that directness more consistently, especially for your main claims.</a:t>
+            </a:r>
+          </a:p>
+          <a:p>
+            <a:r>
+              <a:rPr lang="en-US" sz="1200" b="1" i="0" kern="1200" dirty="0">
+                <a:solidFill>
+                  <a:schemeClr val="tx1"/>
+                </a:solidFill>
+                <a:effectLst/>
+                <a:latin typeface="+mn-lt"/>
+                <a:ea typeface="+mn-ea"/>
+                <a:cs typeface="+mn-cs"/>
+              </a:rPr>
+              <a:t>The K23 aims need a punchier delivery.</a:t>
+            </a:r>
+            <a:r>
+              <a:rPr lang="en-US" sz="1200" b="0" i="0" kern="1200" dirty="0">
+                <a:solidFill>
+                  <a:schemeClr val="tx1"/>
+                </a:solidFill>
+                <a:effectLst/>
+                <a:latin typeface="+mn-lt"/>
+                <a:ea typeface="+mn-ea"/>
+                <a:cs typeface="+mn-cs"/>
+              </a:rPr>
+              <a:t> This is arguably the most important part for your audience, but it arrives when you're running low on time and the framing becomes somewhat list-like. Consider a brief setup sentence: </a:t>
+            </a:r>
+            <a:r>
+              <a:rPr lang="en-US" sz="1200" b="0" i="1" kern="1200" dirty="0">
+                <a:solidFill>
+                  <a:schemeClr val="tx1"/>
+                </a:solidFill>
+                <a:effectLst/>
+                <a:latin typeface="+mn-lt"/>
+                <a:ea typeface="+mn-ea"/>
+                <a:cs typeface="+mn-cs"/>
+              </a:rPr>
+              <a:t>"The K23 has three aims that build on each other: risk stratification, variation characterization, and a pilot nudge intervention."</a:t>
+            </a:r>
+            <a:r>
+              <a:rPr lang="en-US" sz="1200" b="0" i="0" kern="1200" dirty="0">
+                <a:solidFill>
+                  <a:schemeClr val="tx1"/>
+                </a:solidFill>
+                <a:effectLst/>
+                <a:latin typeface="+mn-lt"/>
+                <a:ea typeface="+mn-ea"/>
+                <a:cs typeface="+mn-cs"/>
+              </a:rPr>
+              <a:t> Then elaborate briefly on each rather than threading them into a single run-on thought.</a:t>
+            </a:r>
+          </a:p>
+          <a:p>
+            <a:r>
+              <a:rPr lang="en-US" sz="1200" b="1" i="0" kern="1200" dirty="0">
+                <a:solidFill>
+                  <a:schemeClr val="tx1"/>
+                </a:solidFill>
+                <a:effectLst/>
+                <a:latin typeface="+mn-lt"/>
+                <a:ea typeface="+mn-ea"/>
+                <a:cs typeface="+mn-cs"/>
+              </a:rPr>
+              <a:t>The GLP-1 mention feels tacked </a:t>
+            </a:r>
+            <a:r>
+              <a:rPr lang="en-US" sz="1200" b="1" i="0" kern="1200" dirty="0" err="1">
+                <a:solidFill>
+                  <a:schemeClr val="tx1"/>
+                </a:solidFill>
+                <a:effectLst/>
+                <a:latin typeface="+mn-lt"/>
+                <a:ea typeface="+mn-ea"/>
+                <a:cs typeface="+mn-cs"/>
+              </a:rPr>
+              <a:t>on.</a:t>
+            </a:r>
+            <a:r>
+              <a:rPr lang="en-US" sz="1200" b="0" i="0" kern="1200" dirty="0" err="1">
+                <a:solidFill>
+                  <a:schemeClr val="tx1"/>
+                </a:solidFill>
+                <a:effectLst/>
+                <a:latin typeface="+mn-lt"/>
+                <a:ea typeface="+mn-ea"/>
+                <a:cs typeface="+mn-cs"/>
+              </a:rPr>
+              <a:t>It's</a:t>
+            </a:r>
+            <a:r>
+              <a:rPr lang="en-US" sz="1200" b="0" i="0" kern="1200" dirty="0">
+                <a:solidFill>
+                  <a:schemeClr val="tx1"/>
+                </a:solidFill>
+                <a:effectLst/>
+                <a:latin typeface="+mn-lt"/>
+                <a:ea typeface="+mn-ea"/>
+                <a:cs typeface="+mn-cs"/>
+              </a:rPr>
+              <a:t> an exciting idea but comes as a tangent right before you close. Either give it a real 30-second setup earlier (perhaps when discussing obesity as a risk factor) or save it for Q&amp;A. Dropping it in the last minute without context may confuse rather than excite.</a:t>
+            </a:r>
+          </a:p>
+          <a:p>
+            <a:r>
+              <a:rPr lang="en-US" sz="1200" b="1" i="0" kern="1200" dirty="0">
+                <a:solidFill>
+                  <a:schemeClr val="tx1"/>
+                </a:solidFill>
+                <a:effectLst/>
+                <a:latin typeface="+mn-lt"/>
+                <a:ea typeface="+mn-ea"/>
+                <a:cs typeface="+mn-cs"/>
+              </a:rPr>
+              <a:t>The close is too soft.</a:t>
+            </a:r>
+            <a:r>
+              <a:rPr lang="en-US" sz="1200" b="0" i="0" kern="1200" dirty="0">
+                <a:solidFill>
+                  <a:schemeClr val="tx1"/>
+                </a:solidFill>
+                <a:effectLst/>
+                <a:latin typeface="+mn-lt"/>
+                <a:ea typeface="+mn-ea"/>
+                <a:cs typeface="+mn-cs"/>
+              </a:rPr>
+              <a:t> "I'll sort of end there" undersells a strong talk. Consider a one-sentence summary statement: </a:t>
+            </a:r>
+            <a:r>
+              <a:rPr lang="en-US" sz="1200" b="0" i="1" kern="1200" dirty="0">
+                <a:solidFill>
+                  <a:schemeClr val="tx1"/>
+                </a:solidFill>
+                <a:effectLst/>
+                <a:latin typeface="+mn-lt"/>
+                <a:ea typeface="+mn-ea"/>
+                <a:cs typeface="+mn-cs"/>
+              </a:rPr>
+              <a:t>"In summary, hypercapnic respiratory failure is common, costly, and undertreated — and we're building the data infrastructure and clinical workflows to change that."</a:t>
+            </a:r>
+            <a:r>
+              <a:rPr lang="en-US" sz="1200" b="0" i="0" kern="1200" dirty="0">
+                <a:solidFill>
+                  <a:schemeClr val="tx1"/>
+                </a:solidFill>
+                <a:effectLst/>
+                <a:latin typeface="+mn-lt"/>
+                <a:ea typeface="+mn-ea"/>
+                <a:cs typeface="+mn-cs"/>
+              </a:rPr>
+              <a:t> Then thank people and open for questions.</a:t>
+            </a:r>
+          </a:p>
+          <a:p>
+            <a:r>
+              <a:rPr lang="en-US" sz="1200" b="1" i="0" kern="1200" dirty="0">
+                <a:solidFill>
+                  <a:schemeClr val="tx1"/>
+                </a:solidFill>
+                <a:effectLst/>
+                <a:latin typeface="+mn-lt"/>
+                <a:ea typeface="+mn-ea"/>
+                <a:cs typeface="+mn-cs"/>
+              </a:rPr>
+              <a:t>Time Management</a:t>
+            </a:r>
+          </a:p>
+          <a:p>
+            <a:r>
+              <a:rPr lang="en-US" sz="1200" b="0" i="0" kern="1200" dirty="0">
+                <a:solidFill>
+                  <a:schemeClr val="tx1"/>
+                </a:solidFill>
+                <a:effectLst/>
+                <a:latin typeface="+mn-lt"/>
+                <a:ea typeface="+mn-ea"/>
+                <a:cs typeface="+mn-cs"/>
+              </a:rPr>
+              <a:t>This transcription runs closer to </a:t>
+            </a:r>
+            <a:r>
+              <a:rPr lang="en-US" sz="1200" b="1" i="0" kern="1200" dirty="0">
+                <a:solidFill>
+                  <a:schemeClr val="tx1"/>
+                </a:solidFill>
+                <a:effectLst/>
+                <a:latin typeface="+mn-lt"/>
+                <a:ea typeface="+mn-ea"/>
+                <a:cs typeface="+mn-cs"/>
+              </a:rPr>
+              <a:t>12–13 minutes</a:t>
+            </a:r>
+            <a:r>
+              <a:rPr lang="en-US" sz="1200" b="0" i="0" kern="1200" dirty="0">
+                <a:solidFill>
+                  <a:schemeClr val="tx1"/>
+                </a:solidFill>
+                <a:effectLst/>
+                <a:latin typeface="+mn-lt"/>
+                <a:ea typeface="+mn-ea"/>
+                <a:cs typeface="+mn-cs"/>
+              </a:rPr>
+              <a:t> of spoken delivery. </a:t>
+            </a:r>
+            <a:r>
+              <a:rPr lang="en-US" sz="1200" b="0" i="0" kern="1200">
+                <a:solidFill>
+                  <a:schemeClr val="tx1"/>
+                </a:solidFill>
+                <a:effectLst/>
+                <a:latin typeface="+mn-lt"/>
+                <a:ea typeface="+mn-ea"/>
+                <a:cs typeface="+mn-cs"/>
+              </a:rPr>
+              <a:t>If you have a hard 10-minute cap, the easiest cuts are: (a) shorten the personal introduction, (b) condense the case-definition discussion to one sentence + one visual reference, and (c) cut the GLP-1 aside to Q&amp;A.</a:t>
+            </a:r>
+          </a:p>
+          <a:p>
             <a:endParaRPr lang="en-US" dirty="0"/>
           </a:p>
         </p:txBody>
@@ -880,7 +1956,7 @@
           <a:p>
             <a:fld id="{7F4F0C85-FC02-4C4E-8B1A-6BB950A69184}" type="slidenum">
               <a:rPr lang="en-US" smtClean="0"/>
-              <a:t>4</a:t>
+              <a:t>5</a:t>
             </a:fld>
             <a:endParaRPr lang="en-US"/>
           </a:p>
@@ -1130,7 +2206,7 @@
           <a:p>
             <a:fld id="{7B5031F0-EA56-3740-A29C-52740243DB2E}" type="datetimeFigureOut">
               <a:rPr lang="en-US" smtClean="0"/>
-              <a:t>3/12/26</a:t>
+              <a:t>3/13/26</a:t>
             </a:fld>
             <a:endParaRPr lang="en-US"/>
           </a:p>
@@ -1328,7 +2404,7 @@
           <a:p>
             <a:fld id="{7B5031F0-EA56-3740-A29C-52740243DB2E}" type="datetimeFigureOut">
               <a:rPr lang="en-US" smtClean="0"/>
-              <a:t>3/12/26</a:t>
+              <a:t>3/13/26</a:t>
             </a:fld>
             <a:endParaRPr lang="en-US"/>
           </a:p>
@@ -1536,7 +2612,7 @@
           <a:p>
             <a:fld id="{7B5031F0-EA56-3740-A29C-52740243DB2E}" type="datetimeFigureOut">
               <a:rPr lang="en-US" smtClean="0"/>
-              <a:t>3/12/26</a:t>
+              <a:t>3/13/26</a:t>
             </a:fld>
             <a:endParaRPr lang="en-US"/>
           </a:p>
@@ -1734,7 +2810,7 @@
           <a:p>
             <a:fld id="{7B5031F0-EA56-3740-A29C-52740243DB2E}" type="datetimeFigureOut">
               <a:rPr lang="en-US" smtClean="0"/>
-              <a:t>3/12/26</a:t>
+              <a:t>3/13/26</a:t>
             </a:fld>
             <a:endParaRPr lang="en-US"/>
           </a:p>
@@ -2009,7 +3085,7 @@
           <a:p>
             <a:fld id="{7B5031F0-EA56-3740-A29C-52740243DB2E}" type="datetimeFigureOut">
               <a:rPr lang="en-US" smtClean="0"/>
-              <a:t>3/12/26</a:t>
+              <a:t>3/13/26</a:t>
             </a:fld>
             <a:endParaRPr lang="en-US"/>
           </a:p>
@@ -2274,7 +3350,7 @@
           <a:p>
             <a:fld id="{7B5031F0-EA56-3740-A29C-52740243DB2E}" type="datetimeFigureOut">
               <a:rPr lang="en-US" smtClean="0"/>
-              <a:t>3/12/26</a:t>
+              <a:t>3/13/26</a:t>
             </a:fld>
             <a:endParaRPr lang="en-US"/>
           </a:p>
@@ -2686,7 +3762,7 @@
           <a:p>
             <a:fld id="{7B5031F0-EA56-3740-A29C-52740243DB2E}" type="datetimeFigureOut">
               <a:rPr lang="en-US" smtClean="0"/>
-              <a:t>3/12/26</a:t>
+              <a:t>3/13/26</a:t>
             </a:fld>
             <a:endParaRPr lang="en-US"/>
           </a:p>
@@ -2827,7 +3903,7 @@
           <a:p>
             <a:fld id="{7B5031F0-EA56-3740-A29C-52740243DB2E}" type="datetimeFigureOut">
               <a:rPr lang="en-US" smtClean="0"/>
-              <a:t>3/12/26</a:t>
+              <a:t>3/13/26</a:t>
             </a:fld>
             <a:endParaRPr lang="en-US"/>
           </a:p>
@@ -2940,7 +4016,7 @@
           <a:p>
             <a:fld id="{7B5031F0-EA56-3740-A29C-52740243DB2E}" type="datetimeFigureOut">
               <a:rPr lang="en-US" smtClean="0"/>
-              <a:t>3/12/26</a:t>
+              <a:t>3/13/26</a:t>
             </a:fld>
             <a:endParaRPr lang="en-US"/>
           </a:p>
@@ -3251,7 +4327,7 @@
           <a:p>
             <a:fld id="{7B5031F0-EA56-3740-A29C-52740243DB2E}" type="datetimeFigureOut">
               <a:rPr lang="en-US" smtClean="0"/>
-              <a:t>3/12/26</a:t>
+              <a:t>3/13/26</a:t>
             </a:fld>
             <a:endParaRPr lang="en-US"/>
           </a:p>
@@ -3539,7 +4615,7 @@
           <a:p>
             <a:fld id="{7B5031F0-EA56-3740-A29C-52740243DB2E}" type="datetimeFigureOut">
               <a:rPr lang="en-US" smtClean="0"/>
-              <a:t>3/12/26</a:t>
+              <a:t>3/13/26</a:t>
             </a:fld>
             <a:endParaRPr lang="en-US"/>
           </a:p>
@@ -3783,7 +4859,7 @@
           <a:p>
             <a:fld id="{7B5031F0-EA56-3740-A29C-52740243DB2E}" type="datetimeFigureOut">
               <a:rPr lang="en-US" smtClean="0"/>
-              <a:t>3/12/26</a:t>
+              <a:t>3/13/26</a:t>
             </a:fld>
             <a:endParaRPr lang="en-US"/>
           </a:p>
@@ -5609,7 +6685,7 @@
                 <a:latin typeface="Arial"/>
                 <a:cs typeface="Arial"/>
               </a:rPr>
-              <a:t>First dedicated chronic respiratory failure subspecialist in the IH system</a:t>
+              <a:t>Dedicated chronic respiratory failure subspecialist for Intermountain</a:t>
             </a:r>
           </a:p>
         </p:txBody>
@@ -5881,7 +6957,7 @@
                 </a:solidFill>
                 <a:latin typeface="Arial"/>
               </a:rPr>
-              <a:t>~150/100K</a:t>
+              <a:t>~200/100K</a:t>
             </a:r>
           </a:p>
         </p:txBody>
@@ -6532,6 +7608,979 @@
 </file>
 
 <file path=ppt/slides/slide4.xml><?xml version="1.0" encoding="utf-8"?>
+<p:sld xmlns:a="http://schemas.openxmlformats.org/drawingml/2006/main" xmlns:r="http://schemas.openxmlformats.org/officeDocument/2006/relationships" xmlns:p="http://schemas.openxmlformats.org/presentationml/2006/main">
+  <p:cSld>
+    <p:spTree>
+      <p:nvGrpSpPr>
+        <p:cNvPr id="1" name=""/>
+        <p:cNvGrpSpPr/>
+        <p:nvPr/>
+      </p:nvGrpSpPr>
+      <p:grpSpPr>
+        <a:xfrm>
+          <a:off x="0" y="0"/>
+          <a:ext cx="0" cy="0"/>
+          <a:chOff x="0" y="0"/>
+          <a:chExt cx="0" cy="0"/>
+        </a:xfrm>
+      </p:grpSpPr>
+      <p:sp>
+        <p:nvSpPr>
+          <p:cNvPr id="4" name="TextBox 3">
+            <a:extLst>
+              <a:ext uri="{FF2B5EF4-FFF2-40B4-BE49-F238E27FC236}">
+                <a16:creationId xmlns:a16="http://schemas.microsoft.com/office/drawing/2014/main" id="{EA3CA9C7-03F1-1B45-BF1E-78BBA9C51013}"/>
+              </a:ext>
+            </a:extLst>
+          </p:cNvPr>
+          <p:cNvSpPr txBox="1"/>
+          <p:nvPr/>
+        </p:nvSpPr>
+        <p:spPr>
+          <a:xfrm>
+            <a:off x="762000" y="254000"/>
+            <a:ext cx="5080000" cy="338554"/>
+          </a:xfrm>
+          <a:prstGeom prst="rect">
+            <a:avLst/>
+          </a:prstGeom>
+          <a:noFill/>
+        </p:spPr>
+        <p:txBody>
+          <a:bodyPr vertOverflow="overflow" vert="horz" wrap="square" rtlCol="0" anchor="t">
+            <a:spAutoFit/>
+          </a:bodyPr>
+          <a:lstStyle/>
+          <a:p>
+            <a:pPr algn="l"/>
+            <a:r>
+              <a:rPr lang="en-US" sz="1600" b="1" dirty="0">
+                <a:solidFill>
+                  <a:srgbClr val="4A00E2"/>
+                </a:solidFill>
+                <a:latin typeface="Arial"/>
+                <a:cs typeface="Arial"/>
+              </a:rPr>
+              <a:t>OUR PRIOR WORK</a:t>
+            </a:r>
+          </a:p>
+        </p:txBody>
+      </p:sp>
+      <p:sp>
+        <p:nvSpPr>
+          <p:cNvPr id="5" name="TextBox 4">
+            <a:extLst>
+              <a:ext uri="{FF2B5EF4-FFF2-40B4-BE49-F238E27FC236}">
+                <a16:creationId xmlns:a16="http://schemas.microsoft.com/office/drawing/2014/main" id="{340B80F7-C58D-6D4A-BB0D-095C441CEBAE}"/>
+              </a:ext>
+            </a:extLst>
+          </p:cNvPr>
+          <p:cNvSpPr txBox="1"/>
+          <p:nvPr/>
+        </p:nvSpPr>
+        <p:spPr>
+          <a:xfrm>
+            <a:off x="762000" y="609600"/>
+            <a:ext cx="10668000" cy="707886"/>
+          </a:xfrm>
+          <a:prstGeom prst="rect">
+            <a:avLst/>
+          </a:prstGeom>
+          <a:noFill/>
+        </p:spPr>
+        <p:txBody>
+          <a:bodyPr vertOverflow="overflow" vert="horz" wrap="square" rtlCol="0" anchor="t">
+            <a:spAutoFit/>
+          </a:bodyPr>
+          <a:lstStyle/>
+          <a:p>
+            <a:pPr algn="l"/>
+            <a:r>
+              <a:rPr lang="en-US" sz="2000" b="1">
+                <a:solidFill>
+                  <a:srgbClr val="110057"/>
+                </a:solidFill>
+                <a:latin typeface="Arial"/>
+                <a:cs typeface="Arial"/>
+              </a:rPr>
+              <a:t>The Consistency of Hypercapnic Respiratory Failure Case Definitions in Electronic Health Record Data</a:t>
+            </a:r>
+          </a:p>
+        </p:txBody>
+      </p:sp>
+      <p:sp>
+        <p:nvSpPr>
+          <p:cNvPr id="23" name="Rectangle 22">
+            <a:extLst>
+              <a:ext uri="{FF2B5EF4-FFF2-40B4-BE49-F238E27FC236}">
+                <a16:creationId xmlns:a16="http://schemas.microsoft.com/office/drawing/2014/main" id="{84F02AE4-4867-B449-B293-9D97CD026432}"/>
+              </a:ext>
+            </a:extLst>
+          </p:cNvPr>
+          <p:cNvSpPr/>
+          <p:nvPr/>
+        </p:nvSpPr>
+        <p:spPr>
+          <a:xfrm>
+            <a:off x="0" y="6731000"/>
+            <a:ext cx="12192000" cy="127000"/>
+          </a:xfrm>
+          <a:prstGeom prst="rect">
+            <a:avLst/>
+          </a:prstGeom>
+          <a:solidFill>
+            <a:srgbClr val="4A00E2"/>
+          </a:solidFill>
+          <a:ln w="19050" cap="flat" cmpd="sng" algn="ctr">
+            <a:noFill/>
+            <a:prstDash val="solid"/>
+            <a:miter lim="800000"/>
+          </a:ln>
+        </p:spPr>
+        <p:style>
+          <a:lnRef idx="2">
+            <a:schemeClr val="accent1">
+              <a:shade val="15000"/>
+            </a:schemeClr>
+          </a:lnRef>
+          <a:fillRef idx="1">
+            <a:schemeClr val="accent1"/>
+          </a:fillRef>
+          <a:effectRef idx="0">
+            <a:schemeClr val="accent1"/>
+          </a:effectRef>
+          <a:fontRef idx="minor">
+            <a:schemeClr val="lt1"/>
+          </a:fontRef>
+        </p:style>
+        <p:txBody>
+          <a:bodyPr vertOverflow="clip" horzOverflow="clip" rtlCol="0" anchor="t"/>
+          <a:lstStyle/>
+          <a:p>
+            <a:pPr algn="l"/>
+            <a:endParaRPr lang="en-US"/>
+          </a:p>
+        </p:txBody>
+      </p:sp>
+      <p:sp>
+        <p:nvSpPr>
+          <p:cNvPr id="2" name="TextBox 1">
+            <a:extLst>
+              <a:ext uri="{FF2B5EF4-FFF2-40B4-BE49-F238E27FC236}">
+                <a16:creationId xmlns:a16="http://schemas.microsoft.com/office/drawing/2014/main" id="{CD0CF540-CD3D-5D4E-9991-F922A28460C7}"/>
+              </a:ext>
+            </a:extLst>
+          </p:cNvPr>
+          <p:cNvSpPr txBox="1"/>
+          <p:nvPr/>
+        </p:nvSpPr>
+        <p:spPr>
+          <a:xfrm>
+            <a:off x="762000" y="1346200"/>
+            <a:ext cx="10668000" cy="276999"/>
+          </a:xfrm>
+          <a:prstGeom prst="rect">
+            <a:avLst/>
+          </a:prstGeom>
+          <a:noFill/>
+        </p:spPr>
+        <p:txBody>
+          <a:bodyPr vertOverflow="overflow" vert="horz" wrap="square" rtlCol="0" anchor="t">
+            <a:spAutoFit/>
+          </a:bodyPr>
+          <a:lstStyle/>
+          <a:p>
+            <a:pPr algn="l">
+              <a:buNone/>
+            </a:pPr>
+            <a:r>
+              <a:rPr lang="en-US" sz="1200" b="1" dirty="0">
+                <a:solidFill>
+                  <a:srgbClr val="110057"/>
+                </a:solidFill>
+                <a:latin typeface="Arial"/>
+                <a:cs typeface="Arial"/>
+              </a:rPr>
+              <a:t>Locke BW</a:t>
+            </a:r>
+            <a:r>
+              <a:rPr lang="en-US" sz="1200" dirty="0">
+                <a:solidFill>
+                  <a:srgbClr val="555555"/>
+                </a:solidFill>
+                <a:latin typeface="Arial"/>
+                <a:cs typeface="Arial"/>
+              </a:rPr>
+              <a:t>, Richards WW, Gouripeddi R, Brown JP, Finkelstein J, Sundar KM, </a:t>
+            </a:r>
+            <a:r>
+              <a:rPr lang="en-US" sz="1200" b="1" dirty="0">
+                <a:solidFill>
+                  <a:srgbClr val="110057"/>
+                </a:solidFill>
+                <a:latin typeface="Arial"/>
+                <a:cs typeface="Arial"/>
+              </a:rPr>
+              <a:t>Peltan ID</a:t>
+            </a:r>
+            <a:r>
+              <a:rPr lang="en-US" sz="1200" dirty="0">
+                <a:solidFill>
+                  <a:srgbClr val="555555"/>
+                </a:solidFill>
+                <a:latin typeface="Arial"/>
+                <a:cs typeface="Arial"/>
+              </a:rPr>
+              <a:t>, </a:t>
+            </a:r>
+            <a:r>
+              <a:rPr lang="en-US" sz="1200" b="1" dirty="0">
+                <a:solidFill>
+                  <a:srgbClr val="110057"/>
+                </a:solidFill>
+                <a:latin typeface="Arial"/>
+                <a:cs typeface="Arial"/>
+              </a:rPr>
+              <a:t>Brown SM</a:t>
+            </a:r>
+          </a:p>
+        </p:txBody>
+      </p:sp>
+      <p:sp>
+        <p:nvSpPr>
+          <p:cNvPr id="6" name="Rounded Rectangle 5">
+            <a:extLst>
+              <a:ext uri="{FF2B5EF4-FFF2-40B4-BE49-F238E27FC236}">
+                <a16:creationId xmlns:a16="http://schemas.microsoft.com/office/drawing/2014/main" id="{7499CC07-EBD8-394F-95AF-76BFC9DCEE96}"/>
+              </a:ext>
+            </a:extLst>
+          </p:cNvPr>
+          <p:cNvSpPr/>
+          <p:nvPr/>
+        </p:nvSpPr>
+        <p:spPr>
+          <a:xfrm>
+            <a:off x="762000" y="1879600"/>
+            <a:ext cx="10668000" cy="1016000"/>
+          </a:xfrm>
+          <a:prstGeom prst="roundRect">
+            <a:avLst/>
+          </a:prstGeom>
+          <a:solidFill>
+            <a:srgbClr val="F3F0FF"/>
+          </a:solidFill>
+          <a:ln w="19050" cap="flat" cmpd="sng" algn="ctr">
+            <a:noFill/>
+            <a:prstDash val="solid"/>
+            <a:miter lim="800000"/>
+          </a:ln>
+        </p:spPr>
+        <p:style>
+          <a:lnRef idx="2">
+            <a:schemeClr val="accent1">
+              <a:shade val="15000"/>
+            </a:schemeClr>
+          </a:lnRef>
+          <a:fillRef idx="1">
+            <a:schemeClr val="accent1"/>
+          </a:fillRef>
+          <a:effectRef idx="0">
+            <a:schemeClr val="accent1"/>
+          </a:effectRef>
+          <a:fontRef idx="minor">
+            <a:schemeClr val="lt1"/>
+          </a:fontRef>
+        </p:style>
+        <p:txBody>
+          <a:bodyPr vertOverflow="clip" horzOverflow="clip" rtlCol="0" anchor="t"/>
+          <a:lstStyle/>
+          <a:p>
+            <a:pPr algn="l"/>
+            <a:endParaRPr lang="en-US"/>
+          </a:p>
+        </p:txBody>
+      </p:sp>
+      <p:sp>
+        <p:nvSpPr>
+          <p:cNvPr id="8" name="Rectangle 7">
+            <a:extLst>
+              <a:ext uri="{FF2B5EF4-FFF2-40B4-BE49-F238E27FC236}">
+                <a16:creationId xmlns:a16="http://schemas.microsoft.com/office/drawing/2014/main" id="{E346B36E-C521-3444-99B0-13D949872135}"/>
+              </a:ext>
+            </a:extLst>
+          </p:cNvPr>
+          <p:cNvSpPr/>
+          <p:nvPr/>
+        </p:nvSpPr>
+        <p:spPr>
+          <a:xfrm>
+            <a:off x="762000" y="1879600"/>
+            <a:ext cx="10668000" cy="50800"/>
+          </a:xfrm>
+          <a:prstGeom prst="rect">
+            <a:avLst/>
+          </a:prstGeom>
+          <a:solidFill>
+            <a:srgbClr val="4A00E2"/>
+          </a:solidFill>
+          <a:ln w="19050" cap="flat" cmpd="sng" algn="ctr">
+            <a:noFill/>
+            <a:prstDash val="solid"/>
+            <a:miter lim="800000"/>
+          </a:ln>
+        </p:spPr>
+        <p:style>
+          <a:lnRef idx="2">
+            <a:schemeClr val="accent1">
+              <a:shade val="15000"/>
+            </a:schemeClr>
+          </a:lnRef>
+          <a:fillRef idx="1">
+            <a:schemeClr val="accent1"/>
+          </a:fillRef>
+          <a:effectRef idx="0">
+            <a:schemeClr val="accent1"/>
+          </a:effectRef>
+          <a:fontRef idx="minor">
+            <a:schemeClr val="lt1"/>
+          </a:fontRef>
+        </p:style>
+        <p:txBody>
+          <a:bodyPr vertOverflow="clip" horzOverflow="clip" rtlCol="0" anchor="t"/>
+          <a:lstStyle/>
+          <a:p>
+            <a:pPr algn="l"/>
+            <a:endParaRPr lang="en-US"/>
+          </a:p>
+        </p:txBody>
+      </p:sp>
+      <p:sp>
+        <p:nvSpPr>
+          <p:cNvPr id="9" name="TextBox 8">
+            <a:extLst>
+              <a:ext uri="{FF2B5EF4-FFF2-40B4-BE49-F238E27FC236}">
+                <a16:creationId xmlns:a16="http://schemas.microsoft.com/office/drawing/2014/main" id="{7124E2C8-46FC-9B49-A4C7-9B6DE723C60C}"/>
+              </a:ext>
+            </a:extLst>
+          </p:cNvPr>
+          <p:cNvSpPr txBox="1"/>
+          <p:nvPr/>
+        </p:nvSpPr>
+        <p:spPr>
+          <a:xfrm>
+            <a:off x="952500" y="2006600"/>
+            <a:ext cx="10287000" cy="279400"/>
+          </a:xfrm>
+          <a:prstGeom prst="rect">
+            <a:avLst/>
+          </a:prstGeom>
+          <a:noFill/>
+        </p:spPr>
+        <p:txBody>
+          <a:bodyPr vertOverflow="overflow" vert="horz" wrap="square" rtlCol="0" anchor="t">
+            <a:noAutofit/>
+          </a:bodyPr>
+          <a:lstStyle/>
+          <a:p>
+            <a:pPr algn="l">
+              <a:buNone/>
+            </a:pPr>
+            <a:r>
+              <a:rPr lang="en-US" sz="1600" b="1" dirty="0">
+                <a:solidFill>
+                  <a:srgbClr val="110057"/>
+                </a:solidFill>
+                <a:latin typeface="Arial"/>
+                <a:cs typeface="Arial"/>
+              </a:rPr>
+              <a:t>Key Finding</a:t>
+            </a:r>
+          </a:p>
+        </p:txBody>
+      </p:sp>
+      <p:sp>
+        <p:nvSpPr>
+          <p:cNvPr id="10" name="TextBox 9">
+            <a:extLst>
+              <a:ext uri="{FF2B5EF4-FFF2-40B4-BE49-F238E27FC236}">
+                <a16:creationId xmlns:a16="http://schemas.microsoft.com/office/drawing/2014/main" id="{7821EC88-7EC0-DD4D-B332-59B01BB8D5B4}"/>
+              </a:ext>
+            </a:extLst>
+          </p:cNvPr>
+          <p:cNvSpPr txBox="1"/>
+          <p:nvPr/>
+        </p:nvSpPr>
+        <p:spPr>
+          <a:xfrm>
+            <a:off x="952500" y="2311400"/>
+            <a:ext cx="10287000" cy="508000"/>
+          </a:xfrm>
+          <a:prstGeom prst="rect">
+            <a:avLst/>
+          </a:prstGeom>
+          <a:noFill/>
+        </p:spPr>
+        <p:txBody>
+          <a:bodyPr vertOverflow="overflow" vert="horz" wrap="square" rtlCol="0" anchor="t">
+            <a:noAutofit/>
+          </a:bodyPr>
+          <a:lstStyle/>
+          <a:p>
+            <a:pPr algn="l">
+              <a:buNone/>
+            </a:pPr>
+            <a:r>
+              <a:rPr lang="en-US" sz="1500" dirty="0">
+                <a:solidFill>
+                  <a:srgbClr val="110057"/>
+                </a:solidFill>
+                <a:latin typeface="Arial"/>
+                <a:cs typeface="Arial"/>
+              </a:rPr>
+              <a:t>Published case definitions for hypercapnic respiratory failure identify </a:t>
+            </a:r>
+            <a:r>
+              <a:rPr lang="en-US" sz="1500" b="1" dirty="0">
+                <a:solidFill>
+                  <a:srgbClr val="4A00E2"/>
+                </a:solidFill>
+                <a:latin typeface="Arial"/>
+                <a:cs typeface="Arial"/>
+              </a:rPr>
+              <a:t>meaningfully different cohorts</a:t>
+            </a:r>
+            <a:r>
+              <a:rPr lang="en-US" sz="1500" dirty="0">
+                <a:solidFill>
+                  <a:srgbClr val="110057"/>
+                </a:solidFill>
+                <a:latin typeface="Arial"/>
+                <a:cs typeface="Arial"/>
+              </a:rPr>
+              <a:t>, limiting literature synthesis and agreement on who should be studied or counted</a:t>
+            </a:r>
+          </a:p>
+        </p:txBody>
+      </p:sp>
+      <p:sp>
+        <p:nvSpPr>
+          <p:cNvPr id="11" name="Rounded Rectangle 10">
+            <a:extLst>
+              <a:ext uri="{FF2B5EF4-FFF2-40B4-BE49-F238E27FC236}">
+                <a16:creationId xmlns:a16="http://schemas.microsoft.com/office/drawing/2014/main" id="{F47EA317-F3A1-A64C-A4C8-9B7FCF01E4A4}"/>
+              </a:ext>
+            </a:extLst>
+          </p:cNvPr>
+          <p:cNvSpPr/>
+          <p:nvPr/>
+        </p:nvSpPr>
+        <p:spPr>
+          <a:xfrm>
+            <a:off x="762000" y="3022600"/>
+            <a:ext cx="5232400" cy="2971800"/>
+          </a:xfrm>
+          <a:prstGeom prst="roundRect">
+            <a:avLst/>
+          </a:prstGeom>
+          <a:solidFill>
+            <a:srgbClr val="F3F0FF"/>
+          </a:solidFill>
+          <a:ln w="19050" cap="flat" cmpd="sng" algn="ctr">
+            <a:noFill/>
+            <a:prstDash val="solid"/>
+            <a:miter lim="800000"/>
+          </a:ln>
+        </p:spPr>
+        <p:style>
+          <a:lnRef idx="2">
+            <a:schemeClr val="accent1">
+              <a:shade val="15000"/>
+            </a:schemeClr>
+          </a:lnRef>
+          <a:fillRef idx="1">
+            <a:schemeClr val="accent1"/>
+          </a:fillRef>
+          <a:effectRef idx="0">
+            <a:schemeClr val="accent1"/>
+          </a:effectRef>
+          <a:fontRef idx="minor">
+            <a:schemeClr val="lt1"/>
+          </a:fontRef>
+        </p:style>
+        <p:txBody>
+          <a:bodyPr vertOverflow="clip" horzOverflow="clip" rtlCol="0" anchor="t"/>
+          <a:lstStyle/>
+          <a:p>
+            <a:pPr algn="l"/>
+            <a:endParaRPr lang="en-US"/>
+          </a:p>
+        </p:txBody>
+      </p:sp>
+      <p:sp>
+        <p:nvSpPr>
+          <p:cNvPr id="12" name="TextBox 11">
+            <a:extLst>
+              <a:ext uri="{FF2B5EF4-FFF2-40B4-BE49-F238E27FC236}">
+                <a16:creationId xmlns:a16="http://schemas.microsoft.com/office/drawing/2014/main" id="{FCF7DB52-34E7-504A-91FC-5208C0AAA90D}"/>
+              </a:ext>
+            </a:extLst>
+          </p:cNvPr>
+          <p:cNvSpPr txBox="1"/>
+          <p:nvPr/>
+        </p:nvSpPr>
+        <p:spPr>
+          <a:xfrm>
+            <a:off x="914400" y="3124200"/>
+            <a:ext cx="4927600" cy="254000"/>
+          </a:xfrm>
+          <a:prstGeom prst="rect">
+            <a:avLst/>
+          </a:prstGeom>
+          <a:noFill/>
+        </p:spPr>
+        <p:txBody>
+          <a:bodyPr vertOverflow="overflow" vert="horz" wrap="square" rtlCol="0" anchor="t">
+            <a:noAutofit/>
+          </a:bodyPr>
+          <a:lstStyle/>
+          <a:p>
+            <a:pPr algn="l">
+              <a:buNone/>
+            </a:pPr>
+            <a:r>
+              <a:rPr lang="en-US" sz="1500" b="1" dirty="0">
+                <a:solidFill>
+                  <a:srgbClr val="110057"/>
+                </a:solidFill>
+                <a:latin typeface="Arial"/>
+                <a:cs typeface="Arial"/>
+              </a:rPr>
+              <a:t>Agreement Between Definitions</a:t>
+            </a:r>
+          </a:p>
+        </p:txBody>
+      </p:sp>
+      <p:sp>
+        <p:nvSpPr>
+          <p:cNvPr id="13" name="TextBox 12">
+            <a:extLst>
+              <a:ext uri="{FF2B5EF4-FFF2-40B4-BE49-F238E27FC236}">
+                <a16:creationId xmlns:a16="http://schemas.microsoft.com/office/drawing/2014/main" id="{AFB12501-D79A-8945-A961-DEF66579F4AC}"/>
+              </a:ext>
+            </a:extLst>
+          </p:cNvPr>
+          <p:cNvSpPr txBox="1"/>
+          <p:nvPr/>
+        </p:nvSpPr>
+        <p:spPr>
+          <a:xfrm>
+            <a:off x="914400" y="3378200"/>
+            <a:ext cx="4927600" cy="406400"/>
+          </a:xfrm>
+          <a:prstGeom prst="rect">
+            <a:avLst/>
+          </a:prstGeom>
+          <a:noFill/>
+        </p:spPr>
+        <p:txBody>
+          <a:bodyPr vertOverflow="overflow" vert="horz" wrap="square" rtlCol="0" anchor="t">
+            <a:noAutofit/>
+          </a:bodyPr>
+          <a:lstStyle/>
+          <a:p>
+            <a:pPr algn="l">
+              <a:buNone/>
+            </a:pPr>
+            <a:r>
+              <a:rPr lang="en-US" sz="1200" dirty="0">
+                <a:solidFill>
+                  <a:srgbClr val="555555"/>
+                </a:solidFill>
+                <a:latin typeface="Arial"/>
+                <a:cs typeface="Arial"/>
+              </a:rPr>
+              <a:t>Pairwise Cohen's κ across six definitions — agreement ranges from slight to moderate</a:t>
+            </a:r>
+          </a:p>
+        </p:txBody>
+      </p:sp>
+      <p:sp>
+        <p:nvSpPr>
+          <p:cNvPr id="14" name="Rounded Rectangle 13">
+            <a:extLst>
+              <a:ext uri="{FF2B5EF4-FFF2-40B4-BE49-F238E27FC236}">
+                <a16:creationId xmlns:a16="http://schemas.microsoft.com/office/drawing/2014/main" id="{E139BC5F-865F-F04E-AC8C-B3EC74CC5326}"/>
+              </a:ext>
+            </a:extLst>
+          </p:cNvPr>
+          <p:cNvSpPr/>
+          <p:nvPr/>
+        </p:nvSpPr>
+        <p:spPr>
+          <a:xfrm>
+            <a:off x="6197600" y="3022600"/>
+            <a:ext cx="5232400" cy="2971800"/>
+          </a:xfrm>
+          <a:prstGeom prst="roundRect">
+            <a:avLst/>
+          </a:prstGeom>
+          <a:solidFill>
+            <a:srgbClr val="F3F0FF"/>
+          </a:solidFill>
+          <a:ln w="19050" cap="flat" cmpd="sng" algn="ctr">
+            <a:noFill/>
+            <a:prstDash val="solid"/>
+            <a:miter lim="800000"/>
+          </a:ln>
+        </p:spPr>
+        <p:style>
+          <a:lnRef idx="2">
+            <a:schemeClr val="accent1">
+              <a:shade val="15000"/>
+            </a:schemeClr>
+          </a:lnRef>
+          <a:fillRef idx="1">
+            <a:schemeClr val="accent1"/>
+          </a:fillRef>
+          <a:effectRef idx="0">
+            <a:schemeClr val="accent1"/>
+          </a:effectRef>
+          <a:fontRef idx="minor">
+            <a:schemeClr val="lt1"/>
+          </a:fontRef>
+        </p:style>
+        <p:txBody>
+          <a:bodyPr vertOverflow="clip" horzOverflow="clip" rtlCol="0" anchor="t"/>
+          <a:lstStyle/>
+          <a:p>
+            <a:pPr algn="l"/>
+            <a:endParaRPr lang="en-US"/>
+          </a:p>
+        </p:txBody>
+      </p:sp>
+      <p:sp>
+        <p:nvSpPr>
+          <p:cNvPr id="15" name="TextBox 14">
+            <a:extLst>
+              <a:ext uri="{FF2B5EF4-FFF2-40B4-BE49-F238E27FC236}">
+                <a16:creationId xmlns:a16="http://schemas.microsoft.com/office/drawing/2014/main" id="{2352D696-EDB4-8F46-BB26-DCDE67A5F4C5}"/>
+              </a:ext>
+            </a:extLst>
+          </p:cNvPr>
+          <p:cNvSpPr txBox="1"/>
+          <p:nvPr/>
+        </p:nvSpPr>
+        <p:spPr>
+          <a:xfrm>
+            <a:off x="6350000" y="3124200"/>
+            <a:ext cx="4927600" cy="254000"/>
+          </a:xfrm>
+          <a:prstGeom prst="rect">
+            <a:avLst/>
+          </a:prstGeom>
+          <a:noFill/>
+        </p:spPr>
+        <p:txBody>
+          <a:bodyPr vertOverflow="overflow" vert="horz" wrap="square" rtlCol="0" anchor="t">
+            <a:noAutofit/>
+          </a:bodyPr>
+          <a:lstStyle/>
+          <a:p>
+            <a:pPr algn="l"/>
+            <a:r>
+              <a:rPr lang="en-US" sz="1400" b="1">
+                <a:solidFill>
+                  <a:srgbClr val="110057"/>
+                </a:solidFill>
+                <a:latin typeface="Arial"/>
+                <a:cs typeface="Arial"/>
+              </a:rPr>
+              <a:t>Companion: Diagnostic Model</a:t>
+            </a:r>
+          </a:p>
+        </p:txBody>
+      </p:sp>
+      <p:sp>
+        <p:nvSpPr>
+          <p:cNvPr id="16" name="TextBox 15">
+            <a:extLst>
+              <a:ext uri="{FF2B5EF4-FFF2-40B4-BE49-F238E27FC236}">
+                <a16:creationId xmlns:a16="http://schemas.microsoft.com/office/drawing/2014/main" id="{4AD5F53E-76B2-0149-9DB7-9CE2FD8FF4D5}"/>
+              </a:ext>
+            </a:extLst>
+          </p:cNvPr>
+          <p:cNvSpPr txBox="1"/>
+          <p:nvPr/>
+        </p:nvSpPr>
+        <p:spPr>
+          <a:xfrm>
+            <a:off x="6350000" y="3378200"/>
+            <a:ext cx="4927600" cy="406400"/>
+          </a:xfrm>
+          <a:prstGeom prst="rect">
+            <a:avLst/>
+          </a:prstGeom>
+          <a:noFill/>
+        </p:spPr>
+        <p:txBody>
+          <a:bodyPr vertOverflow="overflow" vert="horz" wrap="square" rtlCol="0" anchor="t">
+            <a:noAutofit/>
+          </a:bodyPr>
+          <a:lstStyle/>
+          <a:p>
+            <a:pPr algn="l">
+              <a:buNone/>
+            </a:pPr>
+            <a:r>
+              <a:rPr lang="en-US" sz="1100" dirty="0">
+                <a:solidFill>
+                  <a:srgbClr val="555555"/>
+                </a:solidFill>
+                <a:latin typeface="Arial"/>
+                <a:cs typeface="Arial"/>
+              </a:rPr>
+              <a:t>Random forest predictions, ROC, &amp; calibration for ML identification of unrecognized hypercapnia (Locke et al. LNAI 2024)</a:t>
+            </a:r>
+          </a:p>
+        </p:txBody>
+      </p:sp>
+      <p:sp>
+        <p:nvSpPr>
+          <p:cNvPr id="17" name="Rectangle 16">
+            <a:extLst>
+              <a:ext uri="{FF2B5EF4-FFF2-40B4-BE49-F238E27FC236}">
+                <a16:creationId xmlns:a16="http://schemas.microsoft.com/office/drawing/2014/main" id="{3F0438F3-8D04-5148-A456-04E23A055CC1}"/>
+              </a:ext>
+            </a:extLst>
+          </p:cNvPr>
+          <p:cNvSpPr/>
+          <p:nvPr/>
+        </p:nvSpPr>
+        <p:spPr>
+          <a:xfrm>
+            <a:off x="762000" y="6096000"/>
+            <a:ext cx="10668000" cy="19050"/>
+          </a:xfrm>
+          <a:prstGeom prst="rect">
+            <a:avLst/>
+          </a:prstGeom>
+          <a:solidFill>
+            <a:srgbClr val="D0D0D0"/>
+          </a:solidFill>
+          <a:ln w="19050" cap="flat" cmpd="sng" algn="ctr">
+            <a:noFill/>
+            <a:prstDash val="solid"/>
+            <a:miter lim="800000"/>
+          </a:ln>
+        </p:spPr>
+        <p:style>
+          <a:lnRef idx="2">
+            <a:schemeClr val="accent1">
+              <a:shade val="15000"/>
+            </a:schemeClr>
+          </a:lnRef>
+          <a:fillRef idx="1">
+            <a:schemeClr val="accent1"/>
+          </a:fillRef>
+          <a:effectRef idx="0">
+            <a:schemeClr val="accent1"/>
+          </a:effectRef>
+          <a:fontRef idx="minor">
+            <a:schemeClr val="lt1"/>
+          </a:fontRef>
+        </p:style>
+        <p:txBody>
+          <a:bodyPr vertOverflow="clip" horzOverflow="clip" rtlCol="0" anchor="t"/>
+          <a:lstStyle/>
+          <a:p>
+            <a:pPr algn="l"/>
+            <a:endParaRPr lang="en-US"/>
+          </a:p>
+        </p:txBody>
+      </p:sp>
+      <p:sp>
+        <p:nvSpPr>
+          <p:cNvPr id="18" name="TextBox 17">
+            <a:extLst>
+              <a:ext uri="{FF2B5EF4-FFF2-40B4-BE49-F238E27FC236}">
+                <a16:creationId xmlns:a16="http://schemas.microsoft.com/office/drawing/2014/main" id="{2DEE4025-177F-F546-8044-BEC7D2E99FE6}"/>
+              </a:ext>
+            </a:extLst>
+          </p:cNvPr>
+          <p:cNvSpPr txBox="1"/>
+          <p:nvPr/>
+        </p:nvSpPr>
+        <p:spPr>
+          <a:xfrm>
+            <a:off x="762000" y="6172200"/>
+            <a:ext cx="10668000" cy="323165"/>
+          </a:xfrm>
+          <a:prstGeom prst="rect">
+            <a:avLst/>
+          </a:prstGeom>
+          <a:noFill/>
+        </p:spPr>
+        <p:txBody>
+          <a:bodyPr vertOverflow="overflow" vert="horz" wrap="square" rtlCol="0" anchor="t">
+            <a:spAutoFit/>
+          </a:bodyPr>
+          <a:lstStyle/>
+          <a:p>
+            <a:pPr algn="l">
+              <a:buNone/>
+            </a:pPr>
+            <a:r>
+              <a:rPr lang="en-US" sz="1500" b="1" dirty="0">
+                <a:solidFill>
+                  <a:srgbClr val="4A00E2"/>
+                </a:solidFill>
+                <a:latin typeface="Arial"/>
+                <a:cs typeface="Arial"/>
+              </a:rPr>
+              <a:t>So what are we doing about it?  </a:t>
+            </a:r>
+            <a:r>
+              <a:rPr lang="en-US" sz="1500" dirty="0">
+                <a:solidFill>
+                  <a:srgbClr val="110057"/>
+                </a:solidFill>
+                <a:latin typeface="Arial"/>
+                <a:cs typeface="Arial"/>
+              </a:rPr>
+              <a:t>A new clinic + funded research to quantify practice patterns at Intermountain </a:t>
+            </a:r>
+            <a:r>
+              <a:rPr lang="en-US" sz="1500" dirty="0">
+                <a:solidFill>
+                  <a:srgbClr val="4A00E2"/>
+                </a:solidFill>
+                <a:latin typeface="Arial"/>
+                <a:cs typeface="Arial"/>
+              </a:rPr>
+              <a:t>→</a:t>
+            </a:r>
+          </a:p>
+        </p:txBody>
+      </p:sp>
+      <p:pic>
+        <p:nvPicPr>
+          <p:cNvPr id="21" name="Picture 20">
+            <a:extLst>
+              <a:ext uri="{FF2B5EF4-FFF2-40B4-BE49-F238E27FC236}">
+                <a16:creationId xmlns:a16="http://schemas.microsoft.com/office/drawing/2014/main" id="{659C04AD-6880-9F25-FCD7-C730A9FC8437}"/>
+              </a:ext>
+            </a:extLst>
+          </p:cNvPr>
+          <p:cNvPicPr>
+            <a:picLocks noChangeAspect="1"/>
+          </p:cNvPicPr>
+          <p:nvPr/>
+        </p:nvPicPr>
+        <p:blipFill>
+          <a:blip r:embed="rId2"/>
+          <a:stretch>
+            <a:fillRect/>
+          </a:stretch>
+        </p:blipFill>
+        <p:spPr>
+          <a:xfrm>
+            <a:off x="2068554" y="3835400"/>
+            <a:ext cx="2619291" cy="2057400"/>
+          </a:xfrm>
+          <a:prstGeom prst="rect">
+            <a:avLst/>
+          </a:prstGeom>
+        </p:spPr>
+      </p:pic>
+      <p:pic>
+        <p:nvPicPr>
+          <p:cNvPr id="30" name="RF Predictions"/>
+          <p:cNvPicPr>
+            <a:picLocks noChangeAspect="1"/>
+          </p:cNvPicPr>
+          <p:nvPr/>
+        </p:nvPicPr>
+        <p:blipFill>
+          <a:blip r:embed="rId3"/>
+          <a:srcRect l="50000" t="7000" b="67000"/>
+          <a:stretch>
+            <a:fillRect/>
+          </a:stretch>
+        </p:blipFill>
+        <p:spPr>
+          <a:xfrm>
+            <a:off x="6324600" y="4597400"/>
+            <a:ext cx="1600200" cy="1200150"/>
+          </a:xfrm>
+          <a:prstGeom prst="rect">
+            <a:avLst/>
+          </a:prstGeom>
+        </p:spPr>
+      </p:pic>
+      <p:pic>
+        <p:nvPicPr>
+          <p:cNvPr id="31" name="RF Discrimination"/>
+          <p:cNvPicPr>
+            <a:picLocks noChangeAspect="1"/>
+          </p:cNvPicPr>
+          <p:nvPr/>
+        </p:nvPicPr>
+        <p:blipFill>
+          <a:blip r:embed="rId3"/>
+          <a:srcRect l="50000" t="33000" b="40000"/>
+          <a:stretch>
+            <a:fillRect/>
+          </a:stretch>
+        </p:blipFill>
+        <p:spPr>
+          <a:xfrm>
+            <a:off x="8001000" y="4546600"/>
+            <a:ext cx="1600200" cy="1248640"/>
+          </a:xfrm>
+          <a:prstGeom prst="rect">
+            <a:avLst/>
+          </a:prstGeom>
+        </p:spPr>
+      </p:pic>
+      <p:pic>
+        <p:nvPicPr>
+          <p:cNvPr id="32" name="RF Calibration"/>
+          <p:cNvPicPr>
+            <a:picLocks noChangeAspect="1"/>
+          </p:cNvPicPr>
+          <p:nvPr/>
+        </p:nvPicPr>
+        <p:blipFill>
+          <a:blip r:embed="rId3"/>
+          <a:srcRect l="50000" t="61000" b="16000"/>
+          <a:stretch>
+            <a:fillRect/>
+          </a:stretch>
+        </p:blipFill>
+        <p:spPr>
+          <a:xfrm>
+            <a:off x="9677400" y="4635500"/>
+            <a:ext cx="1600200" cy="1066800"/>
+          </a:xfrm>
+          <a:prstGeom prst="rect">
+            <a:avLst/>
+          </a:prstGeom>
+        </p:spPr>
+      </p:pic>
+    </p:spTree>
+    <p:extLst>
+      <p:ext uri="{BB962C8B-B14F-4D97-AF65-F5344CB8AC3E}">
+        <p14:creationId xmlns:p14="http://schemas.microsoft.com/office/powerpoint/2010/main" val="1980161072"/>
+      </p:ext>
+    </p:extLst>
+  </p:cSld>
+  <p:clrMapOvr>
+    <a:masterClrMapping/>
+  </p:clrMapOvr>
+</p:sld>
+</file>
+
+<file path=ppt/slides/slide5.xml><?xml version="1.0" encoding="utf-8"?>
 <p:sld xmlns:a="http://schemas.openxmlformats.org/drawingml/2006/main" xmlns:r="http://schemas.openxmlformats.org/officeDocument/2006/relationships" xmlns:p="http://schemas.openxmlformats.org/presentationml/2006/main">
   <p:cSld>
     <p:bg>
@@ -7442,979 +9491,6 @@
 </p:sld>
 </file>
 
-<file path=ppt/slides/slide5.xml><?xml version="1.0" encoding="utf-8"?>
-<p:sld xmlns:a="http://schemas.openxmlformats.org/drawingml/2006/main" xmlns:r="http://schemas.openxmlformats.org/officeDocument/2006/relationships" xmlns:p="http://schemas.openxmlformats.org/presentationml/2006/main">
-  <p:cSld>
-    <p:spTree>
-      <p:nvGrpSpPr>
-        <p:cNvPr id="1" name=""/>
-        <p:cNvGrpSpPr/>
-        <p:nvPr/>
-      </p:nvGrpSpPr>
-      <p:grpSpPr>
-        <a:xfrm>
-          <a:off x="0" y="0"/>
-          <a:ext cx="0" cy="0"/>
-          <a:chOff x="0" y="0"/>
-          <a:chExt cx="0" cy="0"/>
-        </a:xfrm>
-      </p:grpSpPr>
-      <p:sp>
-        <p:nvSpPr>
-          <p:cNvPr id="4" name="TextBox 3">
-            <a:extLst>
-              <a:ext uri="{FF2B5EF4-FFF2-40B4-BE49-F238E27FC236}">
-                <a16:creationId xmlns:a16="http://schemas.microsoft.com/office/drawing/2014/main" id="{EA3CA9C7-03F1-1B45-BF1E-78BBA9C51013}"/>
-              </a:ext>
-            </a:extLst>
-          </p:cNvPr>
-          <p:cNvSpPr txBox="1"/>
-          <p:nvPr/>
-        </p:nvSpPr>
-        <p:spPr>
-          <a:xfrm>
-            <a:off x="762000" y="254000"/>
-            <a:ext cx="5080000" cy="338554"/>
-          </a:xfrm>
-          <a:prstGeom prst="rect">
-            <a:avLst/>
-          </a:prstGeom>
-          <a:noFill/>
-        </p:spPr>
-        <p:txBody>
-          <a:bodyPr vertOverflow="overflow" vert="horz" wrap="square" rtlCol="0" anchor="t">
-            <a:spAutoFit/>
-          </a:bodyPr>
-          <a:lstStyle/>
-          <a:p>
-            <a:pPr algn="l"/>
-            <a:r>
-              <a:rPr lang="en-US" sz="1600" b="1" dirty="0">
-                <a:solidFill>
-                  <a:srgbClr val="4A00E2"/>
-                </a:solidFill>
-                <a:latin typeface="Arial"/>
-                <a:cs typeface="Arial"/>
-              </a:rPr>
-              <a:t>OUR PRIOR WORK</a:t>
-            </a:r>
-          </a:p>
-        </p:txBody>
-      </p:sp>
-      <p:sp>
-        <p:nvSpPr>
-          <p:cNvPr id="5" name="TextBox 4">
-            <a:extLst>
-              <a:ext uri="{FF2B5EF4-FFF2-40B4-BE49-F238E27FC236}">
-                <a16:creationId xmlns:a16="http://schemas.microsoft.com/office/drawing/2014/main" id="{340B80F7-C58D-6D4A-BB0D-095C441CEBAE}"/>
-              </a:ext>
-            </a:extLst>
-          </p:cNvPr>
-          <p:cNvSpPr txBox="1"/>
-          <p:nvPr/>
-        </p:nvSpPr>
-        <p:spPr>
-          <a:xfrm>
-            <a:off x="762000" y="609600"/>
-            <a:ext cx="10668000" cy="707886"/>
-          </a:xfrm>
-          <a:prstGeom prst="rect">
-            <a:avLst/>
-          </a:prstGeom>
-          <a:noFill/>
-        </p:spPr>
-        <p:txBody>
-          <a:bodyPr vertOverflow="overflow" vert="horz" wrap="square" rtlCol="0" anchor="t">
-            <a:spAutoFit/>
-          </a:bodyPr>
-          <a:lstStyle/>
-          <a:p>
-            <a:pPr algn="l"/>
-            <a:r>
-              <a:rPr lang="en-US" sz="2000" b="1">
-                <a:solidFill>
-                  <a:srgbClr val="110057"/>
-                </a:solidFill>
-                <a:latin typeface="Arial"/>
-                <a:cs typeface="Arial"/>
-              </a:rPr>
-              <a:t>The Consistency of Hypercapnic Respiratory Failure Case Definitions in Electronic Health Record Data</a:t>
-            </a:r>
-          </a:p>
-        </p:txBody>
-      </p:sp>
-      <p:sp>
-        <p:nvSpPr>
-          <p:cNvPr id="23" name="Rectangle 22">
-            <a:extLst>
-              <a:ext uri="{FF2B5EF4-FFF2-40B4-BE49-F238E27FC236}">
-                <a16:creationId xmlns:a16="http://schemas.microsoft.com/office/drawing/2014/main" id="{84F02AE4-4867-B449-B293-9D97CD026432}"/>
-              </a:ext>
-            </a:extLst>
-          </p:cNvPr>
-          <p:cNvSpPr/>
-          <p:nvPr/>
-        </p:nvSpPr>
-        <p:spPr>
-          <a:xfrm>
-            <a:off x="0" y="6731000"/>
-            <a:ext cx="12192000" cy="127000"/>
-          </a:xfrm>
-          <a:prstGeom prst="rect">
-            <a:avLst/>
-          </a:prstGeom>
-          <a:solidFill>
-            <a:srgbClr val="4A00E2"/>
-          </a:solidFill>
-          <a:ln w="19050" cap="flat" cmpd="sng" algn="ctr">
-            <a:noFill/>
-            <a:prstDash val="solid"/>
-            <a:miter lim="800000"/>
-          </a:ln>
-        </p:spPr>
-        <p:style>
-          <a:lnRef idx="2">
-            <a:schemeClr val="accent1">
-              <a:shade val="15000"/>
-            </a:schemeClr>
-          </a:lnRef>
-          <a:fillRef idx="1">
-            <a:schemeClr val="accent1"/>
-          </a:fillRef>
-          <a:effectRef idx="0">
-            <a:schemeClr val="accent1"/>
-          </a:effectRef>
-          <a:fontRef idx="minor">
-            <a:schemeClr val="lt1"/>
-          </a:fontRef>
-        </p:style>
-        <p:txBody>
-          <a:bodyPr vertOverflow="clip" horzOverflow="clip" rtlCol="0" anchor="t"/>
-          <a:lstStyle/>
-          <a:p>
-            <a:pPr algn="l"/>
-            <a:endParaRPr lang="en-US"/>
-          </a:p>
-        </p:txBody>
-      </p:sp>
-      <p:sp>
-        <p:nvSpPr>
-          <p:cNvPr id="2" name="TextBox 1">
-            <a:extLst>
-              <a:ext uri="{FF2B5EF4-FFF2-40B4-BE49-F238E27FC236}">
-                <a16:creationId xmlns:a16="http://schemas.microsoft.com/office/drawing/2014/main" id="{CD0CF540-CD3D-5D4E-9991-F922A28460C7}"/>
-              </a:ext>
-            </a:extLst>
-          </p:cNvPr>
-          <p:cNvSpPr txBox="1"/>
-          <p:nvPr/>
-        </p:nvSpPr>
-        <p:spPr>
-          <a:xfrm>
-            <a:off x="762000" y="1346200"/>
-            <a:ext cx="10668000" cy="276999"/>
-          </a:xfrm>
-          <a:prstGeom prst="rect">
-            <a:avLst/>
-          </a:prstGeom>
-          <a:noFill/>
-        </p:spPr>
-        <p:txBody>
-          <a:bodyPr vertOverflow="overflow" vert="horz" wrap="square" rtlCol="0" anchor="t">
-            <a:spAutoFit/>
-          </a:bodyPr>
-          <a:lstStyle/>
-          <a:p>
-            <a:pPr algn="l">
-              <a:buNone/>
-            </a:pPr>
-            <a:r>
-              <a:rPr lang="en-US" sz="1200" b="1" dirty="0">
-                <a:solidFill>
-                  <a:srgbClr val="110057"/>
-                </a:solidFill>
-                <a:latin typeface="Arial"/>
-                <a:cs typeface="Arial"/>
-              </a:rPr>
-              <a:t>Locke BW</a:t>
-            </a:r>
-            <a:r>
-              <a:rPr lang="en-US" sz="1200" dirty="0">
-                <a:solidFill>
-                  <a:srgbClr val="555555"/>
-                </a:solidFill>
-                <a:latin typeface="Arial"/>
-                <a:cs typeface="Arial"/>
-              </a:rPr>
-              <a:t>, Richards WW, Gouripeddi R, Brown JP, Finkelstein J, Sundar KM, </a:t>
-            </a:r>
-            <a:r>
-              <a:rPr lang="en-US" sz="1200" b="1" dirty="0">
-                <a:solidFill>
-                  <a:srgbClr val="110057"/>
-                </a:solidFill>
-                <a:latin typeface="Arial"/>
-                <a:cs typeface="Arial"/>
-              </a:rPr>
-              <a:t>Peltan ID</a:t>
-            </a:r>
-            <a:r>
-              <a:rPr lang="en-US" sz="1200" dirty="0">
-                <a:solidFill>
-                  <a:srgbClr val="555555"/>
-                </a:solidFill>
-                <a:latin typeface="Arial"/>
-                <a:cs typeface="Arial"/>
-              </a:rPr>
-              <a:t>, </a:t>
-            </a:r>
-            <a:r>
-              <a:rPr lang="en-US" sz="1200" b="1" dirty="0">
-                <a:solidFill>
-                  <a:srgbClr val="110057"/>
-                </a:solidFill>
-                <a:latin typeface="Arial"/>
-                <a:cs typeface="Arial"/>
-              </a:rPr>
-              <a:t>Brown SM</a:t>
-            </a:r>
-          </a:p>
-        </p:txBody>
-      </p:sp>
-      <p:sp>
-        <p:nvSpPr>
-          <p:cNvPr id="6" name="Rounded Rectangle 5">
-            <a:extLst>
-              <a:ext uri="{FF2B5EF4-FFF2-40B4-BE49-F238E27FC236}">
-                <a16:creationId xmlns:a16="http://schemas.microsoft.com/office/drawing/2014/main" id="{7499CC07-EBD8-394F-95AF-76BFC9DCEE96}"/>
-              </a:ext>
-            </a:extLst>
-          </p:cNvPr>
-          <p:cNvSpPr/>
-          <p:nvPr/>
-        </p:nvSpPr>
-        <p:spPr>
-          <a:xfrm>
-            <a:off x="762000" y="1879600"/>
-            <a:ext cx="10668000" cy="1016000"/>
-          </a:xfrm>
-          <a:prstGeom prst="roundRect">
-            <a:avLst/>
-          </a:prstGeom>
-          <a:solidFill>
-            <a:srgbClr val="F3F0FF"/>
-          </a:solidFill>
-          <a:ln w="19050" cap="flat" cmpd="sng" algn="ctr">
-            <a:noFill/>
-            <a:prstDash val="solid"/>
-            <a:miter lim="800000"/>
-          </a:ln>
-        </p:spPr>
-        <p:style>
-          <a:lnRef idx="2">
-            <a:schemeClr val="accent1">
-              <a:shade val="15000"/>
-            </a:schemeClr>
-          </a:lnRef>
-          <a:fillRef idx="1">
-            <a:schemeClr val="accent1"/>
-          </a:fillRef>
-          <a:effectRef idx="0">
-            <a:schemeClr val="accent1"/>
-          </a:effectRef>
-          <a:fontRef idx="minor">
-            <a:schemeClr val="lt1"/>
-          </a:fontRef>
-        </p:style>
-        <p:txBody>
-          <a:bodyPr vertOverflow="clip" horzOverflow="clip" rtlCol="0" anchor="t"/>
-          <a:lstStyle/>
-          <a:p>
-            <a:pPr algn="l"/>
-            <a:endParaRPr lang="en-US"/>
-          </a:p>
-        </p:txBody>
-      </p:sp>
-      <p:sp>
-        <p:nvSpPr>
-          <p:cNvPr id="8" name="Rectangle 7">
-            <a:extLst>
-              <a:ext uri="{FF2B5EF4-FFF2-40B4-BE49-F238E27FC236}">
-                <a16:creationId xmlns:a16="http://schemas.microsoft.com/office/drawing/2014/main" id="{E346B36E-C521-3444-99B0-13D949872135}"/>
-              </a:ext>
-            </a:extLst>
-          </p:cNvPr>
-          <p:cNvSpPr/>
-          <p:nvPr/>
-        </p:nvSpPr>
-        <p:spPr>
-          <a:xfrm>
-            <a:off x="762000" y="1879600"/>
-            <a:ext cx="10668000" cy="50800"/>
-          </a:xfrm>
-          <a:prstGeom prst="rect">
-            <a:avLst/>
-          </a:prstGeom>
-          <a:solidFill>
-            <a:srgbClr val="4A00E2"/>
-          </a:solidFill>
-          <a:ln w="19050" cap="flat" cmpd="sng" algn="ctr">
-            <a:noFill/>
-            <a:prstDash val="solid"/>
-            <a:miter lim="800000"/>
-          </a:ln>
-        </p:spPr>
-        <p:style>
-          <a:lnRef idx="2">
-            <a:schemeClr val="accent1">
-              <a:shade val="15000"/>
-            </a:schemeClr>
-          </a:lnRef>
-          <a:fillRef idx="1">
-            <a:schemeClr val="accent1"/>
-          </a:fillRef>
-          <a:effectRef idx="0">
-            <a:schemeClr val="accent1"/>
-          </a:effectRef>
-          <a:fontRef idx="minor">
-            <a:schemeClr val="lt1"/>
-          </a:fontRef>
-        </p:style>
-        <p:txBody>
-          <a:bodyPr vertOverflow="clip" horzOverflow="clip" rtlCol="0" anchor="t"/>
-          <a:lstStyle/>
-          <a:p>
-            <a:pPr algn="l"/>
-            <a:endParaRPr lang="en-US"/>
-          </a:p>
-        </p:txBody>
-      </p:sp>
-      <p:sp>
-        <p:nvSpPr>
-          <p:cNvPr id="9" name="TextBox 8">
-            <a:extLst>
-              <a:ext uri="{FF2B5EF4-FFF2-40B4-BE49-F238E27FC236}">
-                <a16:creationId xmlns:a16="http://schemas.microsoft.com/office/drawing/2014/main" id="{7124E2C8-46FC-9B49-A4C7-9B6DE723C60C}"/>
-              </a:ext>
-            </a:extLst>
-          </p:cNvPr>
-          <p:cNvSpPr txBox="1"/>
-          <p:nvPr/>
-        </p:nvSpPr>
-        <p:spPr>
-          <a:xfrm>
-            <a:off x="952500" y="2006600"/>
-            <a:ext cx="10287000" cy="279400"/>
-          </a:xfrm>
-          <a:prstGeom prst="rect">
-            <a:avLst/>
-          </a:prstGeom>
-          <a:noFill/>
-        </p:spPr>
-        <p:txBody>
-          <a:bodyPr vertOverflow="overflow" vert="horz" wrap="square" rtlCol="0" anchor="t">
-            <a:noAutofit/>
-          </a:bodyPr>
-          <a:lstStyle/>
-          <a:p>
-            <a:pPr algn="l">
-              <a:buNone/>
-            </a:pPr>
-            <a:r>
-              <a:rPr lang="en-US" sz="1600" b="1" dirty="0">
-                <a:solidFill>
-                  <a:srgbClr val="110057"/>
-                </a:solidFill>
-                <a:latin typeface="Arial"/>
-                <a:cs typeface="Arial"/>
-              </a:rPr>
-              <a:t>Key Finding</a:t>
-            </a:r>
-          </a:p>
-        </p:txBody>
-      </p:sp>
-      <p:sp>
-        <p:nvSpPr>
-          <p:cNvPr id="10" name="TextBox 9">
-            <a:extLst>
-              <a:ext uri="{FF2B5EF4-FFF2-40B4-BE49-F238E27FC236}">
-                <a16:creationId xmlns:a16="http://schemas.microsoft.com/office/drawing/2014/main" id="{7821EC88-7EC0-DD4D-B332-59B01BB8D5B4}"/>
-              </a:ext>
-            </a:extLst>
-          </p:cNvPr>
-          <p:cNvSpPr txBox="1"/>
-          <p:nvPr/>
-        </p:nvSpPr>
-        <p:spPr>
-          <a:xfrm>
-            <a:off x="952500" y="2311400"/>
-            <a:ext cx="10287000" cy="508000"/>
-          </a:xfrm>
-          <a:prstGeom prst="rect">
-            <a:avLst/>
-          </a:prstGeom>
-          <a:noFill/>
-        </p:spPr>
-        <p:txBody>
-          <a:bodyPr vertOverflow="overflow" vert="horz" wrap="square" rtlCol="0" anchor="t">
-            <a:noAutofit/>
-          </a:bodyPr>
-          <a:lstStyle/>
-          <a:p>
-            <a:pPr algn="l">
-              <a:buNone/>
-            </a:pPr>
-            <a:r>
-              <a:rPr lang="en-US" sz="1500" dirty="0">
-                <a:solidFill>
-                  <a:srgbClr val="110057"/>
-                </a:solidFill>
-                <a:latin typeface="Arial"/>
-                <a:cs typeface="Arial"/>
-              </a:rPr>
-              <a:t>Published case definitions for hypercapnic respiratory failure identify </a:t>
-            </a:r>
-            <a:r>
-              <a:rPr lang="en-US" sz="1500" b="1" dirty="0">
-                <a:solidFill>
-                  <a:srgbClr val="4A00E2"/>
-                </a:solidFill>
-                <a:latin typeface="Arial"/>
-                <a:cs typeface="Arial"/>
-              </a:rPr>
-              <a:t>meaningfully different cohorts</a:t>
-            </a:r>
-            <a:r>
-              <a:rPr lang="en-US" sz="1500" dirty="0">
-                <a:solidFill>
-                  <a:srgbClr val="110057"/>
-                </a:solidFill>
-                <a:latin typeface="Arial"/>
-                <a:cs typeface="Arial"/>
-              </a:rPr>
-              <a:t>, limiting literature synthesis and agreement on who should be studied or counted</a:t>
-            </a:r>
-          </a:p>
-        </p:txBody>
-      </p:sp>
-      <p:sp>
-        <p:nvSpPr>
-          <p:cNvPr id="11" name="Rounded Rectangle 10">
-            <a:extLst>
-              <a:ext uri="{FF2B5EF4-FFF2-40B4-BE49-F238E27FC236}">
-                <a16:creationId xmlns:a16="http://schemas.microsoft.com/office/drawing/2014/main" id="{F47EA317-F3A1-A64C-A4C8-9B7FCF01E4A4}"/>
-              </a:ext>
-            </a:extLst>
-          </p:cNvPr>
-          <p:cNvSpPr/>
-          <p:nvPr/>
-        </p:nvSpPr>
-        <p:spPr>
-          <a:xfrm>
-            <a:off x="762000" y="3022600"/>
-            <a:ext cx="5232400" cy="2971800"/>
-          </a:xfrm>
-          <a:prstGeom prst="roundRect">
-            <a:avLst/>
-          </a:prstGeom>
-          <a:solidFill>
-            <a:srgbClr val="F3F0FF"/>
-          </a:solidFill>
-          <a:ln w="19050" cap="flat" cmpd="sng" algn="ctr">
-            <a:noFill/>
-            <a:prstDash val="solid"/>
-            <a:miter lim="800000"/>
-          </a:ln>
-        </p:spPr>
-        <p:style>
-          <a:lnRef idx="2">
-            <a:schemeClr val="accent1">
-              <a:shade val="15000"/>
-            </a:schemeClr>
-          </a:lnRef>
-          <a:fillRef idx="1">
-            <a:schemeClr val="accent1"/>
-          </a:fillRef>
-          <a:effectRef idx="0">
-            <a:schemeClr val="accent1"/>
-          </a:effectRef>
-          <a:fontRef idx="minor">
-            <a:schemeClr val="lt1"/>
-          </a:fontRef>
-        </p:style>
-        <p:txBody>
-          <a:bodyPr vertOverflow="clip" horzOverflow="clip" rtlCol="0" anchor="t"/>
-          <a:lstStyle/>
-          <a:p>
-            <a:pPr algn="l"/>
-            <a:endParaRPr lang="en-US"/>
-          </a:p>
-        </p:txBody>
-      </p:sp>
-      <p:sp>
-        <p:nvSpPr>
-          <p:cNvPr id="12" name="TextBox 11">
-            <a:extLst>
-              <a:ext uri="{FF2B5EF4-FFF2-40B4-BE49-F238E27FC236}">
-                <a16:creationId xmlns:a16="http://schemas.microsoft.com/office/drawing/2014/main" id="{FCF7DB52-34E7-504A-91FC-5208C0AAA90D}"/>
-              </a:ext>
-            </a:extLst>
-          </p:cNvPr>
-          <p:cNvSpPr txBox="1"/>
-          <p:nvPr/>
-        </p:nvSpPr>
-        <p:spPr>
-          <a:xfrm>
-            <a:off x="914400" y="3124200"/>
-            <a:ext cx="4927600" cy="254000"/>
-          </a:xfrm>
-          <a:prstGeom prst="rect">
-            <a:avLst/>
-          </a:prstGeom>
-          <a:noFill/>
-        </p:spPr>
-        <p:txBody>
-          <a:bodyPr vertOverflow="overflow" vert="horz" wrap="square" rtlCol="0" anchor="t">
-            <a:noAutofit/>
-          </a:bodyPr>
-          <a:lstStyle/>
-          <a:p>
-            <a:pPr algn="l">
-              <a:buNone/>
-            </a:pPr>
-            <a:r>
-              <a:rPr lang="en-US" sz="1500" b="1" dirty="0">
-                <a:solidFill>
-                  <a:srgbClr val="110057"/>
-                </a:solidFill>
-                <a:latin typeface="Arial"/>
-                <a:cs typeface="Arial"/>
-              </a:rPr>
-              <a:t>Agreement Between Definitions</a:t>
-            </a:r>
-          </a:p>
-        </p:txBody>
-      </p:sp>
-      <p:sp>
-        <p:nvSpPr>
-          <p:cNvPr id="13" name="TextBox 12">
-            <a:extLst>
-              <a:ext uri="{FF2B5EF4-FFF2-40B4-BE49-F238E27FC236}">
-                <a16:creationId xmlns:a16="http://schemas.microsoft.com/office/drawing/2014/main" id="{AFB12501-D79A-8945-A961-DEF66579F4AC}"/>
-              </a:ext>
-            </a:extLst>
-          </p:cNvPr>
-          <p:cNvSpPr txBox="1"/>
-          <p:nvPr/>
-        </p:nvSpPr>
-        <p:spPr>
-          <a:xfrm>
-            <a:off x="914400" y="3378200"/>
-            <a:ext cx="4927600" cy="406400"/>
-          </a:xfrm>
-          <a:prstGeom prst="rect">
-            <a:avLst/>
-          </a:prstGeom>
-          <a:noFill/>
-        </p:spPr>
-        <p:txBody>
-          <a:bodyPr vertOverflow="overflow" vert="horz" wrap="square" rtlCol="0" anchor="t">
-            <a:noAutofit/>
-          </a:bodyPr>
-          <a:lstStyle/>
-          <a:p>
-            <a:pPr algn="l">
-              <a:buNone/>
-            </a:pPr>
-            <a:r>
-              <a:rPr lang="en-US" sz="1200" dirty="0">
-                <a:solidFill>
-                  <a:srgbClr val="555555"/>
-                </a:solidFill>
-                <a:latin typeface="Arial"/>
-                <a:cs typeface="Arial"/>
-              </a:rPr>
-              <a:t>Pairwise Cohen's κ across six definitions — agreement ranges from slight to moderate</a:t>
-            </a:r>
-          </a:p>
-        </p:txBody>
-      </p:sp>
-      <p:sp>
-        <p:nvSpPr>
-          <p:cNvPr id="14" name="Rounded Rectangle 13">
-            <a:extLst>
-              <a:ext uri="{FF2B5EF4-FFF2-40B4-BE49-F238E27FC236}">
-                <a16:creationId xmlns:a16="http://schemas.microsoft.com/office/drawing/2014/main" id="{E139BC5F-865F-F04E-AC8C-B3EC74CC5326}"/>
-              </a:ext>
-            </a:extLst>
-          </p:cNvPr>
-          <p:cNvSpPr/>
-          <p:nvPr/>
-        </p:nvSpPr>
-        <p:spPr>
-          <a:xfrm>
-            <a:off x="6197600" y="3022600"/>
-            <a:ext cx="5232400" cy="2971800"/>
-          </a:xfrm>
-          <a:prstGeom prst="roundRect">
-            <a:avLst/>
-          </a:prstGeom>
-          <a:solidFill>
-            <a:srgbClr val="F3F0FF"/>
-          </a:solidFill>
-          <a:ln w="19050" cap="flat" cmpd="sng" algn="ctr">
-            <a:noFill/>
-            <a:prstDash val="solid"/>
-            <a:miter lim="800000"/>
-          </a:ln>
-        </p:spPr>
-        <p:style>
-          <a:lnRef idx="2">
-            <a:schemeClr val="accent1">
-              <a:shade val="15000"/>
-            </a:schemeClr>
-          </a:lnRef>
-          <a:fillRef idx="1">
-            <a:schemeClr val="accent1"/>
-          </a:fillRef>
-          <a:effectRef idx="0">
-            <a:schemeClr val="accent1"/>
-          </a:effectRef>
-          <a:fontRef idx="minor">
-            <a:schemeClr val="lt1"/>
-          </a:fontRef>
-        </p:style>
-        <p:txBody>
-          <a:bodyPr vertOverflow="clip" horzOverflow="clip" rtlCol="0" anchor="t"/>
-          <a:lstStyle/>
-          <a:p>
-            <a:pPr algn="l"/>
-            <a:endParaRPr lang="en-US"/>
-          </a:p>
-        </p:txBody>
-      </p:sp>
-      <p:sp>
-        <p:nvSpPr>
-          <p:cNvPr id="15" name="TextBox 14">
-            <a:extLst>
-              <a:ext uri="{FF2B5EF4-FFF2-40B4-BE49-F238E27FC236}">
-                <a16:creationId xmlns:a16="http://schemas.microsoft.com/office/drawing/2014/main" id="{2352D696-EDB4-8F46-BB26-DCDE67A5F4C5}"/>
-              </a:ext>
-            </a:extLst>
-          </p:cNvPr>
-          <p:cNvSpPr txBox="1"/>
-          <p:nvPr/>
-        </p:nvSpPr>
-        <p:spPr>
-          <a:xfrm>
-            <a:off x="6350000" y="3124200"/>
-            <a:ext cx="4927600" cy="254000"/>
-          </a:xfrm>
-          <a:prstGeom prst="rect">
-            <a:avLst/>
-          </a:prstGeom>
-          <a:noFill/>
-        </p:spPr>
-        <p:txBody>
-          <a:bodyPr vertOverflow="overflow" vert="horz" wrap="square" rtlCol="0" anchor="t">
-            <a:noAutofit/>
-          </a:bodyPr>
-          <a:lstStyle/>
-          <a:p>
-            <a:pPr algn="l"/>
-            <a:r>
-              <a:rPr lang="en-US" sz="1400" b="1">
-                <a:solidFill>
-                  <a:srgbClr val="110057"/>
-                </a:solidFill>
-                <a:latin typeface="Arial"/>
-                <a:cs typeface="Arial"/>
-              </a:rPr>
-              <a:t>Companion: Diagnostic Model</a:t>
-            </a:r>
-          </a:p>
-        </p:txBody>
-      </p:sp>
-      <p:sp>
-        <p:nvSpPr>
-          <p:cNvPr id="16" name="TextBox 15">
-            <a:extLst>
-              <a:ext uri="{FF2B5EF4-FFF2-40B4-BE49-F238E27FC236}">
-                <a16:creationId xmlns:a16="http://schemas.microsoft.com/office/drawing/2014/main" id="{4AD5F53E-76B2-0149-9DB7-9CE2FD8FF4D5}"/>
-              </a:ext>
-            </a:extLst>
-          </p:cNvPr>
-          <p:cNvSpPr txBox="1"/>
-          <p:nvPr/>
-        </p:nvSpPr>
-        <p:spPr>
-          <a:xfrm>
-            <a:off x="6350000" y="3378200"/>
-            <a:ext cx="4927600" cy="406400"/>
-          </a:xfrm>
-          <a:prstGeom prst="rect">
-            <a:avLst/>
-          </a:prstGeom>
-          <a:noFill/>
-        </p:spPr>
-        <p:txBody>
-          <a:bodyPr vertOverflow="overflow" vert="horz" wrap="square" rtlCol="0" anchor="t">
-            <a:noAutofit/>
-          </a:bodyPr>
-          <a:lstStyle/>
-          <a:p>
-            <a:pPr algn="l">
-              <a:buNone/>
-            </a:pPr>
-            <a:r>
-              <a:rPr lang="en-US" sz="1100" dirty="0">
-                <a:solidFill>
-                  <a:srgbClr val="555555"/>
-                </a:solidFill>
-                <a:latin typeface="Arial"/>
-                <a:cs typeface="Arial"/>
-              </a:rPr>
-              <a:t>Random forest predictions, ROC, &amp; calibration for ML identification of unrecognized hypercapnia (Locke et al. LNAI 2024)</a:t>
-            </a:r>
-          </a:p>
-        </p:txBody>
-      </p:sp>
-      <p:sp>
-        <p:nvSpPr>
-          <p:cNvPr id="17" name="Rectangle 16">
-            <a:extLst>
-              <a:ext uri="{FF2B5EF4-FFF2-40B4-BE49-F238E27FC236}">
-                <a16:creationId xmlns:a16="http://schemas.microsoft.com/office/drawing/2014/main" id="{3F0438F3-8D04-5148-A456-04E23A055CC1}"/>
-              </a:ext>
-            </a:extLst>
-          </p:cNvPr>
-          <p:cNvSpPr/>
-          <p:nvPr/>
-        </p:nvSpPr>
-        <p:spPr>
-          <a:xfrm>
-            <a:off x="762000" y="6096000"/>
-            <a:ext cx="10668000" cy="19050"/>
-          </a:xfrm>
-          <a:prstGeom prst="rect">
-            <a:avLst/>
-          </a:prstGeom>
-          <a:solidFill>
-            <a:srgbClr val="D0D0D0"/>
-          </a:solidFill>
-          <a:ln w="19050" cap="flat" cmpd="sng" algn="ctr">
-            <a:noFill/>
-            <a:prstDash val="solid"/>
-            <a:miter lim="800000"/>
-          </a:ln>
-        </p:spPr>
-        <p:style>
-          <a:lnRef idx="2">
-            <a:schemeClr val="accent1">
-              <a:shade val="15000"/>
-            </a:schemeClr>
-          </a:lnRef>
-          <a:fillRef idx="1">
-            <a:schemeClr val="accent1"/>
-          </a:fillRef>
-          <a:effectRef idx="0">
-            <a:schemeClr val="accent1"/>
-          </a:effectRef>
-          <a:fontRef idx="minor">
-            <a:schemeClr val="lt1"/>
-          </a:fontRef>
-        </p:style>
-        <p:txBody>
-          <a:bodyPr vertOverflow="clip" horzOverflow="clip" rtlCol="0" anchor="t"/>
-          <a:lstStyle/>
-          <a:p>
-            <a:pPr algn="l"/>
-            <a:endParaRPr lang="en-US"/>
-          </a:p>
-        </p:txBody>
-      </p:sp>
-      <p:sp>
-        <p:nvSpPr>
-          <p:cNvPr id="18" name="TextBox 17">
-            <a:extLst>
-              <a:ext uri="{FF2B5EF4-FFF2-40B4-BE49-F238E27FC236}">
-                <a16:creationId xmlns:a16="http://schemas.microsoft.com/office/drawing/2014/main" id="{2DEE4025-177F-F546-8044-BEC7D2E99FE6}"/>
-              </a:ext>
-            </a:extLst>
-          </p:cNvPr>
-          <p:cNvSpPr txBox="1"/>
-          <p:nvPr/>
-        </p:nvSpPr>
-        <p:spPr>
-          <a:xfrm>
-            <a:off x="762000" y="6172200"/>
-            <a:ext cx="10668000" cy="323165"/>
-          </a:xfrm>
-          <a:prstGeom prst="rect">
-            <a:avLst/>
-          </a:prstGeom>
-          <a:noFill/>
-        </p:spPr>
-        <p:txBody>
-          <a:bodyPr vertOverflow="overflow" vert="horz" wrap="square" rtlCol="0" anchor="t">
-            <a:spAutoFit/>
-          </a:bodyPr>
-          <a:lstStyle/>
-          <a:p>
-            <a:pPr algn="l">
-              <a:buNone/>
-            </a:pPr>
-            <a:r>
-              <a:rPr lang="en-US" sz="1500" b="1" dirty="0">
-                <a:solidFill>
-                  <a:srgbClr val="4A00E2"/>
-                </a:solidFill>
-                <a:latin typeface="Arial"/>
-                <a:cs typeface="Arial"/>
-              </a:rPr>
-              <a:t>So what are we doing about it?  </a:t>
-            </a:r>
-            <a:r>
-              <a:rPr lang="en-US" sz="1500" dirty="0">
-                <a:solidFill>
-                  <a:srgbClr val="110057"/>
-                </a:solidFill>
-                <a:latin typeface="Arial"/>
-                <a:cs typeface="Arial"/>
-              </a:rPr>
-              <a:t>A new clinic + funded research to quantify practice patterns at Intermountain </a:t>
-            </a:r>
-            <a:r>
-              <a:rPr lang="en-US" sz="1500" dirty="0">
-                <a:solidFill>
-                  <a:srgbClr val="4A00E2"/>
-                </a:solidFill>
-                <a:latin typeface="Arial"/>
-                <a:cs typeface="Arial"/>
-              </a:rPr>
-              <a:t>→</a:t>
-            </a:r>
-          </a:p>
-        </p:txBody>
-      </p:sp>
-      <p:pic>
-        <p:nvPicPr>
-          <p:cNvPr id="21" name="Picture 20">
-            <a:extLst>
-              <a:ext uri="{FF2B5EF4-FFF2-40B4-BE49-F238E27FC236}">
-                <a16:creationId xmlns:a16="http://schemas.microsoft.com/office/drawing/2014/main" id="{659C04AD-6880-9F25-FCD7-C730A9FC8437}"/>
-              </a:ext>
-            </a:extLst>
-          </p:cNvPr>
-          <p:cNvPicPr>
-            <a:picLocks noChangeAspect="1"/>
-          </p:cNvPicPr>
-          <p:nvPr/>
-        </p:nvPicPr>
-        <p:blipFill>
-          <a:blip r:embed="rId2"/>
-          <a:stretch>
-            <a:fillRect/>
-          </a:stretch>
-        </p:blipFill>
-        <p:spPr>
-          <a:xfrm>
-            <a:off x="2068554" y="3835400"/>
-            <a:ext cx="2619291" cy="2057400"/>
-          </a:xfrm>
-          <a:prstGeom prst="rect">
-            <a:avLst/>
-          </a:prstGeom>
-        </p:spPr>
-      </p:pic>
-      <p:pic>
-        <p:nvPicPr>
-          <p:cNvPr id="30" name="RF Predictions"/>
-          <p:cNvPicPr>
-            <a:picLocks noChangeAspect="1"/>
-          </p:cNvPicPr>
-          <p:nvPr/>
-        </p:nvPicPr>
-        <p:blipFill>
-          <a:blip r:embed="rId3"/>
-          <a:srcRect l="50000" t="7000" b="67000"/>
-          <a:stretch>
-            <a:fillRect/>
-          </a:stretch>
-        </p:blipFill>
-        <p:spPr>
-          <a:xfrm>
-            <a:off x="6324600" y="4597400"/>
-            <a:ext cx="1600200" cy="1200150"/>
-          </a:xfrm>
-          <a:prstGeom prst="rect">
-            <a:avLst/>
-          </a:prstGeom>
-        </p:spPr>
-      </p:pic>
-      <p:pic>
-        <p:nvPicPr>
-          <p:cNvPr id="31" name="RF Discrimination"/>
-          <p:cNvPicPr>
-            <a:picLocks noChangeAspect="1"/>
-          </p:cNvPicPr>
-          <p:nvPr/>
-        </p:nvPicPr>
-        <p:blipFill>
-          <a:blip r:embed="rId3"/>
-          <a:srcRect l="50000" t="33000" b="40000"/>
-          <a:stretch>
-            <a:fillRect/>
-          </a:stretch>
-        </p:blipFill>
-        <p:spPr>
-          <a:xfrm>
-            <a:off x="8001000" y="4546600"/>
-            <a:ext cx="1600200" cy="1248640"/>
-          </a:xfrm>
-          <a:prstGeom prst="rect">
-            <a:avLst/>
-          </a:prstGeom>
-        </p:spPr>
-      </p:pic>
-      <p:pic>
-        <p:nvPicPr>
-          <p:cNvPr id="32" name="RF Calibration"/>
-          <p:cNvPicPr>
-            <a:picLocks noChangeAspect="1"/>
-          </p:cNvPicPr>
-          <p:nvPr/>
-        </p:nvPicPr>
-        <p:blipFill>
-          <a:blip r:embed="rId3"/>
-          <a:srcRect l="50000" t="61000" b="16000"/>
-          <a:stretch>
-            <a:fillRect/>
-          </a:stretch>
-        </p:blipFill>
-        <p:spPr>
-          <a:xfrm>
-            <a:off x="9677400" y="4635500"/>
-            <a:ext cx="1600200" cy="1066800"/>
-          </a:xfrm>
-          <a:prstGeom prst="rect">
-            <a:avLst/>
-          </a:prstGeom>
-        </p:spPr>
-      </p:pic>
-    </p:spTree>
-    <p:extLst>
-      <p:ext uri="{BB962C8B-B14F-4D97-AF65-F5344CB8AC3E}">
-        <p14:creationId xmlns:p14="http://schemas.microsoft.com/office/powerpoint/2010/main" val="1980161072"/>
-      </p:ext>
-    </p:extLst>
-  </p:cSld>
-  <p:clrMapOvr>
-    <a:masterClrMapping/>
-  </p:clrMapOvr>
-</p:sld>
-</file>
-
 <file path=ppt/slides/slide6.xml><?xml version="1.0" encoding="utf-8"?>
 <p:sld xmlns:a="http://schemas.openxmlformats.org/drawingml/2006/main" xmlns:r="http://schemas.openxmlformats.org/officeDocument/2006/relationships" xmlns:p="http://schemas.openxmlformats.org/presentationml/2006/main">
   <p:cSld>
@@ -9157,7 +10233,7 @@
                 <a:latin typeface="Arial"/>
                 <a:cs typeface="Arial"/>
               </a:rPr>
-              <a:t>Consolidates scattered care — including post-discharge device qualification that currently has no clear ownership pathway</a:t>
+              <a:t>Consolidates scattered care: including post-discharge device qualification that currently has no clear ownership pathway</a:t>
             </a:r>
           </a:p>
           <a:p>
@@ -9382,7 +10458,7 @@
         <p:spPr>
           <a:xfrm>
             <a:off x="762000" y="609600"/>
-            <a:ext cx="8890000" cy="508000"/>
+            <a:ext cx="8890000" cy="461665"/>
           </a:xfrm>
           <a:prstGeom prst="rect">
             <a:avLst/>
@@ -9403,7 +10479,7 @@
                 </a:solidFill>
                 <a:latin typeface="Arial"/>
               </a:rPr>
-              <a:t>Two research programs, one grant</a:t>
+              <a:t>Two research programs</a:t>
             </a:r>
           </a:p>
         </p:txBody>

</xml_diff>